<commit_message>
Update pitch deck slides
</commit_message>
<xml_diff>
--- a/pitch-deck-slides.pptx
+++ b/pitch-deck-slides.pptx
@@ -5,25 +5,27 @@
     <p:sldMasterId id="2147483648" r:id="rId1"/>
   </p:sldMasterIdLst>
   <p:sldIdLst>
-    <p:sldId id="256" r:id="rId7"/>
-    <p:sldId id="257" r:id="rId8"/>
-    <p:sldId id="258" r:id="rId9"/>
-    <p:sldId id="259" r:id="rId10"/>
-    <p:sldId id="260" r:id="rId11"/>
-    <p:sldId id="261" r:id="rId12"/>
-    <p:sldId id="262" r:id="rId13"/>
-    <p:sldId id="263" r:id="rId14"/>
-    <p:sldId id="264" r:id="rId15"/>
-    <p:sldId id="265" r:id="rId16"/>
-    <p:sldId id="266" r:id="rId17"/>
-    <p:sldId id="267" r:id="rId18"/>
-    <p:sldId id="268" r:id="rId19"/>
-    <p:sldId id="269" r:id="rId20"/>
-    <p:sldId id="270" r:id="rId21"/>
-    <p:sldId id="271" r:id="rId22"/>
-    <p:sldId id="272" r:id="rId23"/>
+    <p:sldId id="256" r:id="rId2"/>
+    <p:sldId id="257" r:id="rId3"/>
+    <p:sldId id="258" r:id="rId4"/>
+    <p:sldId id="259" r:id="rId5"/>
+    <p:sldId id="260" r:id="rId6"/>
+    <p:sldId id="261" r:id="rId7"/>
+    <p:sldId id="262" r:id="rId8"/>
+    <p:sldId id="263" r:id="rId9"/>
+    <p:sldId id="264" r:id="rId10"/>
+    <p:sldId id="265" r:id="rId11"/>
+    <p:sldId id="266" r:id="rId12"/>
+    <p:sldId id="267" r:id="rId13"/>
+    <p:sldId id="268" r:id="rId14"/>
+    <p:sldId id="269" r:id="rId15"/>
+    <p:sldId id="270" r:id="rId16"/>
+    <p:sldId id="274" r:id="rId17"/>
+    <p:sldId id="275" r:id="rId18"/>
+    <p:sldId id="273" r:id="rId19"/>
+    <p:sldId id="271" r:id="rId20"/>
   </p:sldIdLst>
-  <p:sldSz cx="12191695" cy="6858000" type="screen4x3"/>
+  <p:sldSz cx="12192000" cy="6858000"/>
   <p:notesSz cx="6858000" cy="9144000"/>
   <p:defaultTextStyle>
     <a:defPPr>
@@ -120,6 +122,22 @@
       </a:defRPr>
     </a:lvl9pPr>
   </p:defaultTextStyle>
+  <p:extLst>
+    <p:ext uri="{EFAFB233-063F-42B5-8137-9DF3F51BA10A}">
+      <p15:sldGuideLst xmlns:p15="http://schemas.microsoft.com/office/powerpoint/2012/main">
+        <p15:guide id="1" orient="horz" pos="2160">
+          <p15:clr>
+            <a:srgbClr val="A4A3A4"/>
+          </p15:clr>
+        </p15:guide>
+        <p15:guide id="2" pos="2880">
+          <p15:clr>
+            <a:srgbClr val="A4A3A4"/>
+          </p15:clr>
+        </p15:guide>
+      </p15:sldGuideLst>
+    </p:ext>
+  </p:extLst>
 </p:presentation>
 </file>
 
@@ -161,10 +179,9 @@
           <a:lstStyle/>
           <a:p>
             <a:r>
-              <a:rPr lang="en-US" smtClean="0"/>
+              <a:rPr lang="en-US"/>
               <a:t>Click to edit Master title style</a:t>
             </a:r>
-            <a:endParaRPr lang="en-US"/>
           </a:p>
         </p:txBody>
       </p:sp>
@@ -280,10 +297,9 @@
           </a:lstStyle>
           <a:p>
             <a:r>
-              <a:rPr lang="en-US" smtClean="0"/>
+              <a:rPr lang="en-US"/>
               <a:t>Click to edit Master subtitle style</a:t>
             </a:r>
-            <a:endParaRPr lang="en-US"/>
           </a:p>
         </p:txBody>
       </p:sp>
@@ -304,7 +320,7 @@
           <a:p>
             <a:fld id="{5BCAD085-E8A6-8845-BD4E-CB4CCA059FC4}" type="datetimeFigureOut">
               <a:rPr lang="en-US" smtClean="0"/>
-              <a:t>1/27/13</a:t>
+              <a:t>6/11/26</a:t>
             </a:fld>
             <a:endParaRPr lang="en-US"/>
           </a:p>
@@ -398,10 +414,9 @@
           <a:lstStyle/>
           <a:p>
             <a:r>
-              <a:rPr lang="en-US" smtClean="0"/>
+              <a:rPr lang="en-US"/>
               <a:t>Click to edit Master title style</a:t>
             </a:r>
-            <a:endParaRPr lang="en-US"/>
           </a:p>
         </p:txBody>
       </p:sp>
@@ -422,38 +437,37 @@
           <a:p>
             <a:pPr lvl="0"/>
             <a:r>
-              <a:rPr lang="en-US" smtClean="0"/>
+              <a:rPr lang="en-US"/>
               <a:t>Click to edit Master text styles</a:t>
             </a:r>
           </a:p>
           <a:p>
             <a:pPr lvl="1"/>
             <a:r>
-              <a:rPr lang="en-US" smtClean="0"/>
+              <a:rPr lang="en-US"/>
               <a:t>Second level</a:t>
             </a:r>
           </a:p>
           <a:p>
             <a:pPr lvl="2"/>
             <a:r>
-              <a:rPr lang="en-US" smtClean="0"/>
+              <a:rPr lang="en-US"/>
               <a:t>Third level</a:t>
             </a:r>
           </a:p>
           <a:p>
             <a:pPr lvl="3"/>
             <a:r>
-              <a:rPr lang="en-US" smtClean="0"/>
+              <a:rPr lang="en-US"/>
               <a:t>Fourth level</a:t>
             </a:r>
           </a:p>
           <a:p>
             <a:pPr lvl="4"/>
             <a:r>
-              <a:rPr lang="en-US" smtClean="0"/>
+              <a:rPr lang="en-US"/>
               <a:t>Fifth level</a:t>
             </a:r>
-            <a:endParaRPr lang="en-US"/>
           </a:p>
         </p:txBody>
       </p:sp>
@@ -474,7 +488,7 @@
           <a:p>
             <a:fld id="{5BCAD085-E8A6-8845-BD4E-CB4CCA059FC4}" type="datetimeFigureOut">
               <a:rPr lang="en-US" smtClean="0"/>
-              <a:t>1/27/13</a:t>
+              <a:t>6/11/26</a:t>
             </a:fld>
             <a:endParaRPr lang="en-US"/>
           </a:p>
@@ -573,10 +587,9 @@
           <a:lstStyle/>
           <a:p>
             <a:r>
-              <a:rPr lang="en-US" smtClean="0"/>
+              <a:rPr lang="en-US"/>
               <a:t>Click to edit Master title style</a:t>
             </a:r>
-            <a:endParaRPr lang="en-US"/>
           </a:p>
         </p:txBody>
       </p:sp>
@@ -602,38 +615,37 @@
           <a:p>
             <a:pPr lvl="0"/>
             <a:r>
-              <a:rPr lang="en-US" smtClean="0"/>
+              <a:rPr lang="en-US"/>
               <a:t>Click to edit Master text styles</a:t>
             </a:r>
           </a:p>
           <a:p>
             <a:pPr lvl="1"/>
             <a:r>
-              <a:rPr lang="en-US" smtClean="0"/>
+              <a:rPr lang="en-US"/>
               <a:t>Second level</a:t>
             </a:r>
           </a:p>
           <a:p>
             <a:pPr lvl="2"/>
             <a:r>
-              <a:rPr lang="en-US" smtClean="0"/>
+              <a:rPr lang="en-US"/>
               <a:t>Third level</a:t>
             </a:r>
           </a:p>
           <a:p>
             <a:pPr lvl="3"/>
             <a:r>
-              <a:rPr lang="en-US" smtClean="0"/>
+              <a:rPr lang="en-US"/>
               <a:t>Fourth level</a:t>
             </a:r>
           </a:p>
           <a:p>
             <a:pPr lvl="4"/>
             <a:r>
-              <a:rPr lang="en-US" smtClean="0"/>
+              <a:rPr lang="en-US"/>
               <a:t>Fifth level</a:t>
             </a:r>
-            <a:endParaRPr lang="en-US"/>
           </a:p>
         </p:txBody>
       </p:sp>
@@ -654,7 +666,7 @@
           <a:p>
             <a:fld id="{5BCAD085-E8A6-8845-BD4E-CB4CCA059FC4}" type="datetimeFigureOut">
               <a:rPr lang="en-US" smtClean="0"/>
-              <a:t>1/27/13</a:t>
+              <a:t>6/11/26</a:t>
             </a:fld>
             <a:endParaRPr lang="en-US"/>
           </a:p>
@@ -748,10 +760,9 @@
           <a:lstStyle/>
           <a:p>
             <a:r>
-              <a:rPr lang="en-US" smtClean="0"/>
+              <a:rPr lang="en-US"/>
               <a:t>Click to edit Master title style</a:t>
             </a:r>
-            <a:endParaRPr lang="en-US"/>
           </a:p>
         </p:txBody>
       </p:sp>
@@ -772,38 +783,37 @@
           <a:p>
             <a:pPr lvl="0"/>
             <a:r>
-              <a:rPr lang="en-US" smtClean="0"/>
+              <a:rPr lang="en-US"/>
               <a:t>Click to edit Master text styles</a:t>
             </a:r>
           </a:p>
           <a:p>
             <a:pPr lvl="1"/>
             <a:r>
-              <a:rPr lang="en-US" smtClean="0"/>
+              <a:rPr lang="en-US"/>
               <a:t>Second level</a:t>
             </a:r>
           </a:p>
           <a:p>
             <a:pPr lvl="2"/>
             <a:r>
-              <a:rPr lang="en-US" smtClean="0"/>
+              <a:rPr lang="en-US"/>
               <a:t>Third level</a:t>
             </a:r>
           </a:p>
           <a:p>
             <a:pPr lvl="3"/>
             <a:r>
-              <a:rPr lang="en-US" smtClean="0"/>
+              <a:rPr lang="en-US"/>
               <a:t>Fourth level</a:t>
             </a:r>
           </a:p>
           <a:p>
             <a:pPr lvl="4"/>
             <a:r>
-              <a:rPr lang="en-US" smtClean="0"/>
+              <a:rPr lang="en-US"/>
               <a:t>Fifth level</a:t>
             </a:r>
-            <a:endParaRPr lang="en-US"/>
           </a:p>
         </p:txBody>
       </p:sp>
@@ -824,7 +834,7 @@
           <a:p>
             <a:fld id="{5BCAD085-E8A6-8845-BD4E-CB4CCA059FC4}" type="datetimeFigureOut">
               <a:rPr lang="en-US" smtClean="0"/>
-              <a:t>1/27/13</a:t>
+              <a:t>6/11/26</a:t>
             </a:fld>
             <a:endParaRPr lang="en-US"/>
           </a:p>
@@ -927,10 +937,9 @@
           </a:lstStyle>
           <a:p>
             <a:r>
-              <a:rPr lang="en-US" smtClean="0"/>
+              <a:rPr lang="en-US"/>
               <a:t>Click to edit Master title style</a:t>
             </a:r>
-            <a:endParaRPr lang="en-US"/>
           </a:p>
         </p:txBody>
       </p:sp>
@@ -1047,7 +1056,7 @@
           <a:p>
             <a:pPr lvl="0"/>
             <a:r>
-              <a:rPr lang="en-US" smtClean="0"/>
+              <a:rPr lang="en-US"/>
               <a:t>Click to edit Master text styles</a:t>
             </a:r>
           </a:p>
@@ -1070,7 +1079,7 @@
           <a:p>
             <a:fld id="{5BCAD085-E8A6-8845-BD4E-CB4CCA059FC4}" type="datetimeFigureOut">
               <a:rPr lang="en-US" smtClean="0"/>
-              <a:t>1/27/13</a:t>
+              <a:t>6/11/26</a:t>
             </a:fld>
             <a:endParaRPr lang="en-US"/>
           </a:p>
@@ -1164,10 +1173,9 @@
           <a:lstStyle/>
           <a:p>
             <a:r>
-              <a:rPr lang="en-US" smtClean="0"/>
+              <a:rPr lang="en-US"/>
               <a:t>Click to edit Master title style</a:t>
             </a:r>
-            <a:endParaRPr lang="en-US"/>
           </a:p>
         </p:txBody>
       </p:sp>
@@ -1221,38 +1229,37 @@
           <a:p>
             <a:pPr lvl="0"/>
             <a:r>
-              <a:rPr lang="en-US" smtClean="0"/>
+              <a:rPr lang="en-US"/>
               <a:t>Click to edit Master text styles</a:t>
             </a:r>
           </a:p>
           <a:p>
             <a:pPr lvl="1"/>
             <a:r>
-              <a:rPr lang="en-US" smtClean="0"/>
+              <a:rPr lang="en-US"/>
               <a:t>Second level</a:t>
             </a:r>
           </a:p>
           <a:p>
             <a:pPr lvl="2"/>
             <a:r>
-              <a:rPr lang="en-US" smtClean="0"/>
+              <a:rPr lang="en-US"/>
               <a:t>Third level</a:t>
             </a:r>
           </a:p>
           <a:p>
             <a:pPr lvl="3"/>
             <a:r>
-              <a:rPr lang="en-US" smtClean="0"/>
+              <a:rPr lang="en-US"/>
               <a:t>Fourth level</a:t>
             </a:r>
           </a:p>
           <a:p>
             <a:pPr lvl="4"/>
             <a:r>
-              <a:rPr lang="en-US" smtClean="0"/>
+              <a:rPr lang="en-US"/>
               <a:t>Fifth level</a:t>
             </a:r>
-            <a:endParaRPr lang="en-US"/>
           </a:p>
         </p:txBody>
       </p:sp>
@@ -1306,38 +1313,37 @@
           <a:p>
             <a:pPr lvl="0"/>
             <a:r>
-              <a:rPr lang="en-US" smtClean="0"/>
+              <a:rPr lang="en-US"/>
               <a:t>Click to edit Master text styles</a:t>
             </a:r>
           </a:p>
           <a:p>
             <a:pPr lvl="1"/>
             <a:r>
-              <a:rPr lang="en-US" smtClean="0"/>
+              <a:rPr lang="en-US"/>
               <a:t>Second level</a:t>
             </a:r>
           </a:p>
           <a:p>
             <a:pPr lvl="2"/>
             <a:r>
-              <a:rPr lang="en-US" smtClean="0"/>
+              <a:rPr lang="en-US"/>
               <a:t>Third level</a:t>
             </a:r>
           </a:p>
           <a:p>
             <a:pPr lvl="3"/>
             <a:r>
-              <a:rPr lang="en-US" smtClean="0"/>
+              <a:rPr lang="en-US"/>
               <a:t>Fourth level</a:t>
             </a:r>
           </a:p>
           <a:p>
             <a:pPr lvl="4"/>
             <a:r>
-              <a:rPr lang="en-US" smtClean="0"/>
+              <a:rPr lang="en-US"/>
               <a:t>Fifth level</a:t>
             </a:r>
-            <a:endParaRPr lang="en-US"/>
           </a:p>
         </p:txBody>
       </p:sp>
@@ -1358,7 +1364,7 @@
           <a:p>
             <a:fld id="{5BCAD085-E8A6-8845-BD4E-CB4CCA059FC4}" type="datetimeFigureOut">
               <a:rPr lang="en-US" smtClean="0"/>
-              <a:t>1/27/13</a:t>
+              <a:t>6/11/26</a:t>
             </a:fld>
             <a:endParaRPr lang="en-US"/>
           </a:p>
@@ -1456,10 +1462,9 @@
           </a:lstStyle>
           <a:p>
             <a:r>
-              <a:rPr lang="en-US" smtClean="0"/>
+              <a:rPr lang="en-US"/>
               <a:t>Click to edit Master title style</a:t>
             </a:r>
-            <a:endParaRPr lang="en-US"/>
           </a:p>
         </p:txBody>
       </p:sp>
@@ -1522,7 +1527,7 @@
           <a:p>
             <a:pPr lvl="0"/>
             <a:r>
-              <a:rPr lang="en-US" smtClean="0"/>
+              <a:rPr lang="en-US"/>
               <a:t>Click to edit Master text styles</a:t>
             </a:r>
           </a:p>
@@ -1578,38 +1583,37 @@
           <a:p>
             <a:pPr lvl="0"/>
             <a:r>
-              <a:rPr lang="en-US" smtClean="0"/>
+              <a:rPr lang="en-US"/>
               <a:t>Click to edit Master text styles</a:t>
             </a:r>
           </a:p>
           <a:p>
             <a:pPr lvl="1"/>
             <a:r>
-              <a:rPr lang="en-US" smtClean="0"/>
+              <a:rPr lang="en-US"/>
               <a:t>Second level</a:t>
             </a:r>
           </a:p>
           <a:p>
             <a:pPr lvl="2"/>
             <a:r>
-              <a:rPr lang="en-US" smtClean="0"/>
+              <a:rPr lang="en-US"/>
               <a:t>Third level</a:t>
             </a:r>
           </a:p>
           <a:p>
             <a:pPr lvl="3"/>
             <a:r>
-              <a:rPr lang="en-US" smtClean="0"/>
+              <a:rPr lang="en-US"/>
               <a:t>Fourth level</a:t>
             </a:r>
           </a:p>
           <a:p>
             <a:pPr lvl="4"/>
             <a:r>
-              <a:rPr lang="en-US" smtClean="0"/>
+              <a:rPr lang="en-US"/>
               <a:t>Fifth level</a:t>
             </a:r>
-            <a:endParaRPr lang="en-US"/>
           </a:p>
         </p:txBody>
       </p:sp>
@@ -1672,7 +1676,7 @@
           <a:p>
             <a:pPr lvl="0"/>
             <a:r>
-              <a:rPr lang="en-US" smtClean="0"/>
+              <a:rPr lang="en-US"/>
               <a:t>Click to edit Master text styles</a:t>
             </a:r>
           </a:p>
@@ -1728,38 +1732,37 @@
           <a:p>
             <a:pPr lvl="0"/>
             <a:r>
-              <a:rPr lang="en-US" smtClean="0"/>
+              <a:rPr lang="en-US"/>
               <a:t>Click to edit Master text styles</a:t>
             </a:r>
           </a:p>
           <a:p>
             <a:pPr lvl="1"/>
             <a:r>
-              <a:rPr lang="en-US" smtClean="0"/>
+              <a:rPr lang="en-US"/>
               <a:t>Second level</a:t>
             </a:r>
           </a:p>
           <a:p>
             <a:pPr lvl="2"/>
             <a:r>
-              <a:rPr lang="en-US" smtClean="0"/>
+              <a:rPr lang="en-US"/>
               <a:t>Third level</a:t>
             </a:r>
           </a:p>
           <a:p>
             <a:pPr lvl="3"/>
             <a:r>
-              <a:rPr lang="en-US" smtClean="0"/>
+              <a:rPr lang="en-US"/>
               <a:t>Fourth level</a:t>
             </a:r>
           </a:p>
           <a:p>
             <a:pPr lvl="4"/>
             <a:r>
-              <a:rPr lang="en-US" smtClean="0"/>
+              <a:rPr lang="en-US"/>
               <a:t>Fifth level</a:t>
             </a:r>
-            <a:endParaRPr lang="en-US"/>
           </a:p>
         </p:txBody>
       </p:sp>
@@ -1780,7 +1783,7 @@
           <a:p>
             <a:fld id="{5BCAD085-E8A6-8845-BD4E-CB4CCA059FC4}" type="datetimeFigureOut">
               <a:rPr lang="en-US" smtClean="0"/>
-              <a:t>1/27/13</a:t>
+              <a:t>6/11/26</a:t>
             </a:fld>
             <a:endParaRPr lang="en-US"/>
           </a:p>
@@ -1874,10 +1877,9 @@
           <a:lstStyle/>
           <a:p>
             <a:r>
-              <a:rPr lang="en-US" smtClean="0"/>
+              <a:rPr lang="en-US"/>
               <a:t>Click to edit Master title style</a:t>
             </a:r>
-            <a:endParaRPr lang="en-US"/>
           </a:p>
         </p:txBody>
       </p:sp>
@@ -1898,7 +1900,7 @@
           <a:p>
             <a:fld id="{5BCAD085-E8A6-8845-BD4E-CB4CCA059FC4}" type="datetimeFigureOut">
               <a:rPr lang="en-US" smtClean="0"/>
-              <a:t>1/27/13</a:t>
+              <a:t>6/11/26</a:t>
             </a:fld>
             <a:endParaRPr lang="en-US"/>
           </a:p>
@@ -1993,7 +1995,7 @@
           <a:p>
             <a:fld id="{5BCAD085-E8A6-8845-BD4E-CB4CCA059FC4}" type="datetimeFigureOut">
               <a:rPr lang="en-US" smtClean="0"/>
-              <a:t>1/27/13</a:t>
+              <a:t>6/11/26</a:t>
             </a:fld>
             <a:endParaRPr lang="en-US"/>
           </a:p>
@@ -2096,10 +2098,9 @@
           </a:lstStyle>
           <a:p>
             <a:r>
-              <a:rPr lang="en-US" smtClean="0"/>
+              <a:rPr lang="en-US"/>
               <a:t>Click to edit Master title style</a:t>
             </a:r>
-            <a:endParaRPr lang="en-US"/>
           </a:p>
         </p:txBody>
       </p:sp>
@@ -2153,38 +2154,37 @@
           <a:p>
             <a:pPr lvl="0"/>
             <a:r>
-              <a:rPr lang="en-US" smtClean="0"/>
+              <a:rPr lang="en-US"/>
               <a:t>Click to edit Master text styles</a:t>
             </a:r>
           </a:p>
           <a:p>
             <a:pPr lvl="1"/>
             <a:r>
-              <a:rPr lang="en-US" smtClean="0"/>
+              <a:rPr lang="en-US"/>
               <a:t>Second level</a:t>
             </a:r>
           </a:p>
           <a:p>
             <a:pPr lvl="2"/>
             <a:r>
-              <a:rPr lang="en-US" smtClean="0"/>
+              <a:rPr lang="en-US"/>
               <a:t>Third level</a:t>
             </a:r>
           </a:p>
           <a:p>
             <a:pPr lvl="3"/>
             <a:r>
-              <a:rPr lang="en-US" smtClean="0"/>
+              <a:rPr lang="en-US"/>
               <a:t>Fourth level</a:t>
             </a:r>
           </a:p>
           <a:p>
             <a:pPr lvl="4"/>
             <a:r>
-              <a:rPr lang="en-US" smtClean="0"/>
+              <a:rPr lang="en-US"/>
               <a:t>Fifth level</a:t>
             </a:r>
-            <a:endParaRPr lang="en-US"/>
           </a:p>
         </p:txBody>
       </p:sp>
@@ -2247,7 +2247,7 @@
           <a:p>
             <a:pPr lvl="0"/>
             <a:r>
-              <a:rPr lang="en-US" smtClean="0"/>
+              <a:rPr lang="en-US"/>
               <a:t>Click to edit Master text styles</a:t>
             </a:r>
           </a:p>
@@ -2270,7 +2270,7 @@
           <a:p>
             <a:fld id="{5BCAD085-E8A6-8845-BD4E-CB4CCA059FC4}" type="datetimeFigureOut">
               <a:rPr lang="en-US" smtClean="0"/>
-              <a:t>1/27/13</a:t>
+              <a:t>6/11/26</a:t>
             </a:fld>
             <a:endParaRPr lang="en-US"/>
           </a:p>
@@ -2373,10 +2373,9 @@
           </a:lstStyle>
           <a:p>
             <a:r>
-              <a:rPr lang="en-US" smtClean="0"/>
+              <a:rPr lang="en-US"/>
               <a:t>Click to edit Master title style</a:t>
             </a:r>
-            <a:endParaRPr lang="en-US"/>
           </a:p>
         </p:txBody>
       </p:sp>
@@ -2500,7 +2499,7 @@
           <a:p>
             <a:pPr lvl="0"/>
             <a:r>
-              <a:rPr lang="en-US" smtClean="0"/>
+              <a:rPr lang="en-US"/>
               <a:t>Click to edit Master text styles</a:t>
             </a:r>
           </a:p>
@@ -2523,7 +2522,7 @@
           <a:p>
             <a:fld id="{5BCAD085-E8A6-8845-BD4E-CB4CCA059FC4}" type="datetimeFigureOut">
               <a:rPr lang="en-US" smtClean="0"/>
-              <a:t>1/27/13</a:t>
+              <a:t>6/11/26</a:t>
             </a:fld>
             <a:endParaRPr lang="en-US"/>
           </a:p>
@@ -2632,10 +2631,9 @@
           <a:lstStyle/>
           <a:p>
             <a:r>
-              <a:rPr lang="en-US" smtClean="0"/>
+              <a:rPr lang="en-US"/>
               <a:t>Click to edit Master title style</a:t>
             </a:r>
-            <a:endParaRPr lang="en-US"/>
           </a:p>
         </p:txBody>
       </p:sp>
@@ -2666,38 +2664,37 @@
           <a:p>
             <a:pPr lvl="0"/>
             <a:r>
-              <a:rPr lang="en-US" smtClean="0"/>
+              <a:rPr lang="en-US"/>
               <a:t>Click to edit Master text styles</a:t>
             </a:r>
           </a:p>
           <a:p>
             <a:pPr lvl="1"/>
             <a:r>
-              <a:rPr lang="en-US" smtClean="0"/>
+              <a:rPr lang="en-US"/>
               <a:t>Second level</a:t>
             </a:r>
           </a:p>
           <a:p>
             <a:pPr lvl="2"/>
             <a:r>
-              <a:rPr lang="en-US" smtClean="0"/>
+              <a:rPr lang="en-US"/>
               <a:t>Third level</a:t>
             </a:r>
           </a:p>
           <a:p>
             <a:pPr lvl="3"/>
             <a:r>
-              <a:rPr lang="en-US" smtClean="0"/>
+              <a:rPr lang="en-US"/>
               <a:t>Fourth level</a:t>
             </a:r>
           </a:p>
           <a:p>
             <a:pPr lvl="4"/>
             <a:r>
-              <a:rPr lang="en-US" smtClean="0"/>
+              <a:rPr lang="en-US"/>
               <a:t>Fifth level</a:t>
             </a:r>
-            <a:endParaRPr lang="en-US"/>
           </a:p>
         </p:txBody>
       </p:sp>
@@ -2736,7 +2733,7 @@
           <a:p>
             <a:fld id="{5BCAD085-E8A6-8845-BD4E-CB4CCA059FC4}" type="datetimeFigureOut">
               <a:rPr lang="en-US" smtClean="0"/>
-              <a:t>1/27/13</a:t>
+              <a:t>6/11/26</a:t>
             </a:fld>
             <a:endParaRPr lang="en-US"/>
           </a:p>
@@ -3095,7 +3092,7 @@
 </file>
 
 <file path=ppt/slides/slide1.xml><?xml version="1.0" encoding="utf-8"?>
-<p:sld xmlns:a="http://schemas.openxmlformats.org/drawingml/2006/main" xmlns:p="http://schemas.openxmlformats.org/presentationml/2006/main" xmlns:r="http://schemas.openxmlformats.org/officeDocument/2006/relationships">
+<p:sld xmlns:a="http://schemas.openxmlformats.org/drawingml/2006/main" xmlns:r="http://schemas.openxmlformats.org/officeDocument/2006/relationships" xmlns:p="http://schemas.openxmlformats.org/presentationml/2006/main">
   <p:cSld>
     <p:bg>
       <p:bgPr>
@@ -3111,7 +3108,14 @@
         <p:cNvGrpSpPr/>
         <p:nvPr/>
       </p:nvGrpSpPr>
-      <p:grpSpPr/>
+      <p:grpSpPr>
+        <a:xfrm>
+          <a:off x="0" y="0"/>
+          <a:ext cx="0" cy="0"/>
+          <a:chOff x="0" y="0"/>
+          <a:chExt cx="0" cy="0"/>
+        </a:xfrm>
+      </p:grpSpPr>
       <p:sp>
         <p:nvSpPr>
           <p:cNvPr id="2" name="TextBox 1"/>
@@ -3244,7 +3248,7 @@
 </file>
 
 <file path=ppt/slides/slide10.xml><?xml version="1.0" encoding="utf-8"?>
-<p:sld xmlns:a="http://schemas.openxmlformats.org/drawingml/2006/main" xmlns:p="http://schemas.openxmlformats.org/presentationml/2006/main" xmlns:r="http://schemas.openxmlformats.org/officeDocument/2006/relationships">
+<p:sld xmlns:a="http://schemas.openxmlformats.org/drawingml/2006/main" xmlns:r="http://schemas.openxmlformats.org/officeDocument/2006/relationships" xmlns:p="http://schemas.openxmlformats.org/presentationml/2006/main">
   <p:cSld>
     <p:bg>
       <p:bgPr>
@@ -3260,7 +3264,14 @@
         <p:cNvGrpSpPr/>
         <p:nvPr/>
       </p:nvGrpSpPr>
-      <p:grpSpPr/>
+      <p:grpSpPr>
+        <a:xfrm>
+          <a:off x="0" y="0"/>
+          <a:ext cx="0" cy="0"/>
+          <a:chOff x="0" y="0"/>
+          <a:chExt cx="0" cy="0"/>
+        </a:xfrm>
+      </p:grpSpPr>
       <p:sp>
         <p:nvSpPr>
           <p:cNvPr id="2" name="TextBox 1"/>
@@ -3350,9 +3361,27 @@
                 <a:tableStyleId>{5C22544A-7EE6-4342-B048-85BDC9FD1C3A}</a:tableStyleId>
               </a:tblPr>
               <a:tblGrid>
-                <a:gridCol w="3627120"/>
-                <a:gridCol w="3627120"/>
-                <a:gridCol w="3627120"/>
+                <a:gridCol w="3627120">
+                  <a:extLst>
+                    <a:ext uri="{9D8B030D-6E8A-4147-A177-3AD203B41FA5}">
+                      <a16:colId xmlns:a16="http://schemas.microsoft.com/office/drawing/2014/main" val="20000"/>
+                    </a:ext>
+                  </a:extLst>
+                </a:gridCol>
+                <a:gridCol w="3627120">
+                  <a:extLst>
+                    <a:ext uri="{9D8B030D-6E8A-4147-A177-3AD203B41FA5}">
+                      <a16:colId xmlns:a16="http://schemas.microsoft.com/office/drawing/2014/main" val="20001"/>
+                    </a:ext>
+                  </a:extLst>
+                </a:gridCol>
+                <a:gridCol w="3627120">
+                  <a:extLst>
+                    <a:ext uri="{9D8B030D-6E8A-4147-A177-3AD203B41FA5}">
+                      <a16:colId xmlns:a16="http://schemas.microsoft.com/office/drawing/2014/main" val="20002"/>
+                    </a:ext>
+                  </a:extLst>
+                </a:gridCol>
               </a:tblGrid>
               <a:tr h="457200">
                 <a:tc>
@@ -3424,6 +3453,11 @@
                     </a:solidFill>
                   </a:tcPr>
                 </a:tc>
+                <a:extLst>
+                  <a:ext uri="{0D108BD9-81ED-4DB2-BD59-A6C34878D82A}">
+                    <a16:rowId xmlns:a16="http://schemas.microsoft.com/office/drawing/2014/main" val="10000"/>
+                  </a:ext>
+                </a:extLst>
               </a:tr>
               <a:tr h="457200">
                 <a:tc>
@@ -3495,6 +3529,11 @@
                     </a:solidFill>
                   </a:tcPr>
                 </a:tc>
+                <a:extLst>
+                  <a:ext uri="{0D108BD9-81ED-4DB2-BD59-A6C34878D82A}">
+                    <a16:rowId xmlns:a16="http://schemas.microsoft.com/office/drawing/2014/main" val="10001"/>
+                  </a:ext>
+                </a:extLst>
               </a:tr>
               <a:tr h="457200">
                 <a:tc>
@@ -3566,6 +3605,11 @@
                     </a:solidFill>
                   </a:tcPr>
                 </a:tc>
+                <a:extLst>
+                  <a:ext uri="{0D108BD9-81ED-4DB2-BD59-A6C34878D82A}">
+                    <a16:rowId xmlns:a16="http://schemas.microsoft.com/office/drawing/2014/main" val="10002"/>
+                  </a:ext>
+                </a:extLst>
               </a:tr>
               <a:tr h="457200">
                 <a:tc>
@@ -3637,6 +3681,11 @@
                     </a:solidFill>
                   </a:tcPr>
                 </a:tc>
+                <a:extLst>
+                  <a:ext uri="{0D108BD9-81ED-4DB2-BD59-A6C34878D82A}">
+                    <a16:rowId xmlns:a16="http://schemas.microsoft.com/office/drawing/2014/main" val="10003"/>
+                  </a:ext>
+                </a:extLst>
               </a:tr>
               <a:tr h="457200">
                 <a:tc>
@@ -3708,6 +3757,11 @@
                     </a:solidFill>
                   </a:tcPr>
                 </a:tc>
+                <a:extLst>
+                  <a:ext uri="{0D108BD9-81ED-4DB2-BD59-A6C34878D82A}">
+                    <a16:rowId xmlns:a16="http://schemas.microsoft.com/office/drawing/2014/main" val="10004"/>
+                  </a:ext>
+                </a:extLst>
               </a:tr>
             </a:tbl>
           </a:graphicData>
@@ -3775,7 +3829,7 @@
 </file>
 
 <file path=ppt/slides/slide11.xml><?xml version="1.0" encoding="utf-8"?>
-<p:sld xmlns:a="http://schemas.openxmlformats.org/drawingml/2006/main" xmlns:p="http://schemas.openxmlformats.org/presentationml/2006/main" xmlns:r="http://schemas.openxmlformats.org/officeDocument/2006/relationships">
+<p:sld xmlns:a="http://schemas.openxmlformats.org/drawingml/2006/main" xmlns:r="http://schemas.openxmlformats.org/officeDocument/2006/relationships" xmlns:p="http://schemas.openxmlformats.org/presentationml/2006/main">
   <p:cSld>
     <p:bg>
       <p:bgPr>
@@ -3791,7 +3845,14 @@
         <p:cNvGrpSpPr/>
         <p:nvPr/>
       </p:nvGrpSpPr>
-      <p:grpSpPr/>
+      <p:grpSpPr>
+        <a:xfrm>
+          <a:off x="0" y="0"/>
+          <a:ext cx="0" cy="0"/>
+          <a:chOff x="0" y="0"/>
+          <a:chExt cx="0" cy="0"/>
+        </a:xfrm>
+      </p:grpSpPr>
       <p:sp>
         <p:nvSpPr>
           <p:cNvPr id="2" name="TextBox 1"/>
@@ -3846,9 +3907,27 @@
                 <a:tableStyleId>{5C22544A-7EE6-4342-B048-85BDC9FD1C3A}</a:tableStyleId>
               </a:tblPr>
               <a:tblGrid>
-                <a:gridCol w="3627120"/>
-                <a:gridCol w="3627120"/>
-                <a:gridCol w="3627120"/>
+                <a:gridCol w="3627120">
+                  <a:extLst>
+                    <a:ext uri="{9D8B030D-6E8A-4147-A177-3AD203B41FA5}">
+                      <a16:colId xmlns:a16="http://schemas.microsoft.com/office/drawing/2014/main" val="20000"/>
+                    </a:ext>
+                  </a:extLst>
+                </a:gridCol>
+                <a:gridCol w="3627120">
+                  <a:extLst>
+                    <a:ext uri="{9D8B030D-6E8A-4147-A177-3AD203B41FA5}">
+                      <a16:colId xmlns:a16="http://schemas.microsoft.com/office/drawing/2014/main" val="20001"/>
+                    </a:ext>
+                  </a:extLst>
+                </a:gridCol>
+                <a:gridCol w="3627120">
+                  <a:extLst>
+                    <a:ext uri="{9D8B030D-6E8A-4147-A177-3AD203B41FA5}">
+                      <a16:colId xmlns:a16="http://schemas.microsoft.com/office/drawing/2014/main" val="20002"/>
+                    </a:ext>
+                  </a:extLst>
+                </a:gridCol>
               </a:tblGrid>
               <a:tr h="457200">
                 <a:tc>
@@ -3920,6 +3999,11 @@
                     </a:solidFill>
                   </a:tcPr>
                 </a:tc>
+                <a:extLst>
+                  <a:ext uri="{0D108BD9-81ED-4DB2-BD59-A6C34878D82A}">
+                    <a16:rowId xmlns:a16="http://schemas.microsoft.com/office/drawing/2014/main" val="10000"/>
+                  </a:ext>
+                </a:extLst>
               </a:tr>
               <a:tr h="457200">
                 <a:tc>
@@ -3991,6 +4075,11 @@
                     </a:solidFill>
                   </a:tcPr>
                 </a:tc>
+                <a:extLst>
+                  <a:ext uri="{0D108BD9-81ED-4DB2-BD59-A6C34878D82A}">
+                    <a16:rowId xmlns:a16="http://schemas.microsoft.com/office/drawing/2014/main" val="10001"/>
+                  </a:ext>
+                </a:extLst>
               </a:tr>
               <a:tr h="457200">
                 <a:tc>
@@ -4062,6 +4151,11 @@
                     </a:solidFill>
                   </a:tcPr>
                 </a:tc>
+                <a:extLst>
+                  <a:ext uri="{0D108BD9-81ED-4DB2-BD59-A6C34878D82A}">
+                    <a16:rowId xmlns:a16="http://schemas.microsoft.com/office/drawing/2014/main" val="10002"/>
+                  </a:ext>
+                </a:extLst>
               </a:tr>
               <a:tr h="457200">
                 <a:tc>
@@ -4133,6 +4227,11 @@
                     </a:solidFill>
                   </a:tcPr>
                 </a:tc>
+                <a:extLst>
+                  <a:ext uri="{0D108BD9-81ED-4DB2-BD59-A6C34878D82A}">
+                    <a16:rowId xmlns:a16="http://schemas.microsoft.com/office/drawing/2014/main" val="10003"/>
+                  </a:ext>
+                </a:extLst>
               </a:tr>
             </a:tbl>
           </a:graphicData>
@@ -4200,7 +4299,7 @@
 </file>
 
 <file path=ppt/slides/slide12.xml><?xml version="1.0" encoding="utf-8"?>
-<p:sld xmlns:a="http://schemas.openxmlformats.org/drawingml/2006/main" xmlns:p="http://schemas.openxmlformats.org/presentationml/2006/main" xmlns:r="http://schemas.openxmlformats.org/officeDocument/2006/relationships">
+<p:sld xmlns:a="http://schemas.openxmlformats.org/drawingml/2006/main" xmlns:r="http://schemas.openxmlformats.org/officeDocument/2006/relationships" xmlns:p="http://schemas.openxmlformats.org/presentationml/2006/main">
   <p:cSld>
     <p:bg>
       <p:bgPr>
@@ -4216,7 +4315,14 @@
         <p:cNvGrpSpPr/>
         <p:nvPr/>
       </p:nvGrpSpPr>
-      <p:grpSpPr/>
+      <p:grpSpPr>
+        <a:xfrm>
+          <a:off x="0" y="0"/>
+          <a:ext cx="0" cy="0"/>
+          <a:chOff x="0" y="0"/>
+          <a:chExt cx="0" cy="0"/>
+        </a:xfrm>
+      </p:grpSpPr>
       <p:sp>
         <p:nvSpPr>
           <p:cNvPr id="2" name="TextBox 1"/>
@@ -4459,7 +4565,7 @@
 </file>
 
 <file path=ppt/slides/slide13.xml><?xml version="1.0" encoding="utf-8"?>
-<p:sld xmlns:a="http://schemas.openxmlformats.org/drawingml/2006/main" xmlns:p="http://schemas.openxmlformats.org/presentationml/2006/main" xmlns:r="http://schemas.openxmlformats.org/officeDocument/2006/relationships">
+<p:sld xmlns:a="http://schemas.openxmlformats.org/drawingml/2006/main" xmlns:r="http://schemas.openxmlformats.org/officeDocument/2006/relationships" xmlns:p="http://schemas.openxmlformats.org/presentationml/2006/main">
   <p:cSld>
     <p:bg>
       <p:bgPr>
@@ -4475,7 +4581,14 @@
         <p:cNvGrpSpPr/>
         <p:nvPr/>
       </p:nvGrpSpPr>
-      <p:grpSpPr/>
+      <p:grpSpPr>
+        <a:xfrm>
+          <a:off x="0" y="0"/>
+          <a:ext cx="0" cy="0"/>
+          <a:chOff x="0" y="0"/>
+          <a:chExt cx="0" cy="0"/>
+        </a:xfrm>
+      </p:grpSpPr>
       <p:sp>
         <p:nvSpPr>
           <p:cNvPr id="2" name="TextBox 1"/>
@@ -4530,9 +4643,27 @@
                 <a:tableStyleId>{5C22544A-7EE6-4342-B048-85BDC9FD1C3A}</a:tableStyleId>
               </a:tblPr>
               <a:tblGrid>
-                <a:gridCol w="3627120"/>
-                <a:gridCol w="3627120"/>
-                <a:gridCol w="3627120"/>
+                <a:gridCol w="3627120">
+                  <a:extLst>
+                    <a:ext uri="{9D8B030D-6E8A-4147-A177-3AD203B41FA5}">
+                      <a16:colId xmlns:a16="http://schemas.microsoft.com/office/drawing/2014/main" val="20000"/>
+                    </a:ext>
+                  </a:extLst>
+                </a:gridCol>
+                <a:gridCol w="3627120">
+                  <a:extLst>
+                    <a:ext uri="{9D8B030D-6E8A-4147-A177-3AD203B41FA5}">
+                      <a16:colId xmlns:a16="http://schemas.microsoft.com/office/drawing/2014/main" val="20001"/>
+                    </a:ext>
+                  </a:extLst>
+                </a:gridCol>
+                <a:gridCol w="3627120">
+                  <a:extLst>
+                    <a:ext uri="{9D8B030D-6E8A-4147-A177-3AD203B41FA5}">
+                      <a16:colId xmlns:a16="http://schemas.microsoft.com/office/drawing/2014/main" val="20002"/>
+                    </a:ext>
+                  </a:extLst>
+                </a:gridCol>
               </a:tblGrid>
               <a:tr h="457200">
                 <a:tc>
@@ -4604,6 +4735,11 @@
                     </a:solidFill>
                   </a:tcPr>
                 </a:tc>
+                <a:extLst>
+                  <a:ext uri="{0D108BD9-81ED-4DB2-BD59-A6C34878D82A}">
+                    <a16:rowId xmlns:a16="http://schemas.microsoft.com/office/drawing/2014/main" val="10000"/>
+                  </a:ext>
+                </a:extLst>
               </a:tr>
               <a:tr h="457200">
                 <a:tc>
@@ -4675,6 +4811,11 @@
                     </a:solidFill>
                   </a:tcPr>
                 </a:tc>
+                <a:extLst>
+                  <a:ext uri="{0D108BD9-81ED-4DB2-BD59-A6C34878D82A}">
+                    <a16:rowId xmlns:a16="http://schemas.microsoft.com/office/drawing/2014/main" val="10001"/>
+                  </a:ext>
+                </a:extLst>
               </a:tr>
               <a:tr h="457200">
                 <a:tc>
@@ -4746,6 +4887,11 @@
                     </a:solidFill>
                   </a:tcPr>
                 </a:tc>
+                <a:extLst>
+                  <a:ext uri="{0D108BD9-81ED-4DB2-BD59-A6C34878D82A}">
+                    <a16:rowId xmlns:a16="http://schemas.microsoft.com/office/drawing/2014/main" val="10002"/>
+                  </a:ext>
+                </a:extLst>
               </a:tr>
             </a:tbl>
           </a:graphicData>
@@ -4798,6 +4944,7 @@
                 </a:solidFill>
               </a:defRPr>
             </a:pPr>
+            <a:endParaRPr/>
           </a:p>
           <a:p>
             <a:pPr>
@@ -4855,7 +5002,7 @@
 </file>
 
 <file path=ppt/slides/slide14.xml><?xml version="1.0" encoding="utf-8"?>
-<p:sld xmlns:a="http://schemas.openxmlformats.org/drawingml/2006/main" xmlns:p="http://schemas.openxmlformats.org/presentationml/2006/main" xmlns:r="http://schemas.openxmlformats.org/officeDocument/2006/relationships">
+<p:sld xmlns:a="http://schemas.openxmlformats.org/drawingml/2006/main" xmlns:r="http://schemas.openxmlformats.org/officeDocument/2006/relationships" xmlns:p="http://schemas.openxmlformats.org/presentationml/2006/main">
   <p:cSld>
     <p:bg>
       <p:bgPr>
@@ -4871,7 +5018,14 @@
         <p:cNvGrpSpPr/>
         <p:nvPr/>
       </p:nvGrpSpPr>
-      <p:grpSpPr/>
+      <p:grpSpPr>
+        <a:xfrm>
+          <a:off x="0" y="0"/>
+          <a:ext cx="0" cy="0"/>
+          <a:chOff x="0" y="0"/>
+          <a:chExt cx="0" cy="0"/>
+        </a:xfrm>
+      </p:grpSpPr>
       <p:sp>
         <p:nvSpPr>
           <p:cNvPr id="2" name="TextBox 1"/>
@@ -4961,10 +5115,34 @@
                 <a:tableStyleId>{5C22544A-7EE6-4342-B048-85BDC9FD1C3A}</a:tableStyleId>
               </a:tblPr>
               <a:tblGrid>
-                <a:gridCol w="2720340"/>
-                <a:gridCol w="2720340"/>
-                <a:gridCol w="2720340"/>
-                <a:gridCol w="2720340"/>
+                <a:gridCol w="2720340">
+                  <a:extLst>
+                    <a:ext uri="{9D8B030D-6E8A-4147-A177-3AD203B41FA5}">
+                      <a16:colId xmlns:a16="http://schemas.microsoft.com/office/drawing/2014/main" val="20000"/>
+                    </a:ext>
+                  </a:extLst>
+                </a:gridCol>
+                <a:gridCol w="2720340">
+                  <a:extLst>
+                    <a:ext uri="{9D8B030D-6E8A-4147-A177-3AD203B41FA5}">
+                      <a16:colId xmlns:a16="http://schemas.microsoft.com/office/drawing/2014/main" val="20001"/>
+                    </a:ext>
+                  </a:extLst>
+                </a:gridCol>
+                <a:gridCol w="2720340">
+                  <a:extLst>
+                    <a:ext uri="{9D8B030D-6E8A-4147-A177-3AD203B41FA5}">
+                      <a16:colId xmlns:a16="http://schemas.microsoft.com/office/drawing/2014/main" val="20002"/>
+                    </a:ext>
+                  </a:extLst>
+                </a:gridCol>
+                <a:gridCol w="2720340">
+                  <a:extLst>
+                    <a:ext uri="{9D8B030D-6E8A-4147-A177-3AD203B41FA5}">
+                      <a16:colId xmlns:a16="http://schemas.microsoft.com/office/drawing/2014/main" val="20003"/>
+                    </a:ext>
+                  </a:extLst>
+                </a:gridCol>
               </a:tblGrid>
               <a:tr h="457200">
                 <a:tc>
@@ -5059,6 +5237,11 @@
                     </a:solidFill>
                   </a:tcPr>
                 </a:tc>
+                <a:extLst>
+                  <a:ext uri="{0D108BD9-81ED-4DB2-BD59-A6C34878D82A}">
+                    <a16:rowId xmlns:a16="http://schemas.microsoft.com/office/drawing/2014/main" val="10000"/>
+                  </a:ext>
+                </a:extLst>
               </a:tr>
               <a:tr h="457200">
                 <a:tc>
@@ -5153,6 +5336,11 @@
                     </a:solidFill>
                   </a:tcPr>
                 </a:tc>
+                <a:extLst>
+                  <a:ext uri="{0D108BD9-81ED-4DB2-BD59-A6C34878D82A}">
+                    <a16:rowId xmlns:a16="http://schemas.microsoft.com/office/drawing/2014/main" val="10001"/>
+                  </a:ext>
+                </a:extLst>
               </a:tr>
               <a:tr h="457200">
                 <a:tc>
@@ -5247,6 +5435,11 @@
                     </a:solidFill>
                   </a:tcPr>
                 </a:tc>
+                <a:extLst>
+                  <a:ext uri="{0D108BD9-81ED-4DB2-BD59-A6C34878D82A}">
+                    <a16:rowId xmlns:a16="http://schemas.microsoft.com/office/drawing/2014/main" val="10002"/>
+                  </a:ext>
+                </a:extLst>
               </a:tr>
               <a:tr h="457200">
                 <a:tc>
@@ -5341,6 +5534,11 @@
                     </a:solidFill>
                   </a:tcPr>
                 </a:tc>
+                <a:extLst>
+                  <a:ext uri="{0D108BD9-81ED-4DB2-BD59-A6C34878D82A}">
+                    <a16:rowId xmlns:a16="http://schemas.microsoft.com/office/drawing/2014/main" val="10003"/>
+                  </a:ext>
+                </a:extLst>
               </a:tr>
             </a:tbl>
           </a:graphicData>
@@ -5391,7 +5589,7 @@
         </p:nvGraphicFramePr>
         <p:xfrm>
           <a:off x="640080" y="3749039"/>
-          <a:ext cx="10881360" cy="1828800"/>
+          <a:ext cx="10881360" cy="1859280"/>
         </p:xfrm>
         <a:graphic>
           <a:graphicData uri="http://schemas.openxmlformats.org/drawingml/2006/table">
@@ -5400,10 +5598,34 @@
                 <a:tableStyleId>{5C22544A-7EE6-4342-B048-85BDC9FD1C3A}</a:tableStyleId>
               </a:tblPr>
               <a:tblGrid>
-                <a:gridCol w="2720340"/>
-                <a:gridCol w="2720340"/>
-                <a:gridCol w="2720340"/>
-                <a:gridCol w="2720340"/>
+                <a:gridCol w="2720340">
+                  <a:extLst>
+                    <a:ext uri="{9D8B030D-6E8A-4147-A177-3AD203B41FA5}">
+                      <a16:colId xmlns:a16="http://schemas.microsoft.com/office/drawing/2014/main" val="20000"/>
+                    </a:ext>
+                  </a:extLst>
+                </a:gridCol>
+                <a:gridCol w="2720340">
+                  <a:extLst>
+                    <a:ext uri="{9D8B030D-6E8A-4147-A177-3AD203B41FA5}">
+                      <a16:colId xmlns:a16="http://schemas.microsoft.com/office/drawing/2014/main" val="20001"/>
+                    </a:ext>
+                  </a:extLst>
+                </a:gridCol>
+                <a:gridCol w="2720340">
+                  <a:extLst>
+                    <a:ext uri="{9D8B030D-6E8A-4147-A177-3AD203B41FA5}">
+                      <a16:colId xmlns:a16="http://schemas.microsoft.com/office/drawing/2014/main" val="20002"/>
+                    </a:ext>
+                  </a:extLst>
+                </a:gridCol>
+                <a:gridCol w="2720340">
+                  <a:extLst>
+                    <a:ext uri="{9D8B030D-6E8A-4147-A177-3AD203B41FA5}">
+                      <a16:colId xmlns:a16="http://schemas.microsoft.com/office/drawing/2014/main" val="20003"/>
+                    </a:ext>
+                  </a:extLst>
+                </a:gridCol>
               </a:tblGrid>
               <a:tr h="457200">
                 <a:tc>
@@ -5498,6 +5720,11 @@
                     </a:solidFill>
                   </a:tcPr>
                 </a:tc>
+                <a:extLst>
+                  <a:ext uri="{0D108BD9-81ED-4DB2-BD59-A6C34878D82A}">
+                    <a16:rowId xmlns:a16="http://schemas.microsoft.com/office/drawing/2014/main" val="10000"/>
+                  </a:ext>
+                </a:extLst>
               </a:tr>
               <a:tr h="457200">
                 <a:tc>
@@ -5592,6 +5819,11 @@
                     </a:solidFill>
                   </a:tcPr>
                 </a:tc>
+                <a:extLst>
+                  <a:ext uri="{0D108BD9-81ED-4DB2-BD59-A6C34878D82A}">
+                    <a16:rowId xmlns:a16="http://schemas.microsoft.com/office/drawing/2014/main" val="10001"/>
+                  </a:ext>
+                </a:extLst>
               </a:tr>
               <a:tr h="457200">
                 <a:tc>
@@ -5686,6 +5918,11 @@
                     </a:solidFill>
                   </a:tcPr>
                 </a:tc>
+                <a:extLst>
+                  <a:ext uri="{0D108BD9-81ED-4DB2-BD59-A6C34878D82A}">
+                    <a16:rowId xmlns:a16="http://schemas.microsoft.com/office/drawing/2014/main" val="10002"/>
+                  </a:ext>
+                </a:extLst>
               </a:tr>
               <a:tr h="457200">
                 <a:tc>
@@ -5780,6 +6017,11 @@
                     </a:solidFill>
                   </a:tcPr>
                 </a:tc>
+                <a:extLst>
+                  <a:ext uri="{0D108BD9-81ED-4DB2-BD59-A6C34878D82A}">
+                    <a16:rowId xmlns:a16="http://schemas.microsoft.com/office/drawing/2014/main" val="10003"/>
+                  </a:ext>
+                </a:extLst>
               </a:tr>
             </a:tbl>
           </a:graphicData>
@@ -5877,6 +6119,7 @@
                 </a:solidFill>
               </a:defRPr>
             </a:pPr>
+            <a:endParaRPr/>
           </a:p>
           <a:p>
             <a:pPr>
@@ -5904,7 +6147,7 @@
 </file>
 
 <file path=ppt/slides/slide15.xml><?xml version="1.0" encoding="utf-8"?>
-<p:sld xmlns:a="http://schemas.openxmlformats.org/drawingml/2006/main" xmlns:p="http://schemas.openxmlformats.org/presentationml/2006/main" xmlns:r="http://schemas.openxmlformats.org/officeDocument/2006/relationships">
+<p:sld xmlns:a="http://schemas.openxmlformats.org/drawingml/2006/main" xmlns:r="http://schemas.openxmlformats.org/officeDocument/2006/relationships" xmlns:p="http://schemas.openxmlformats.org/presentationml/2006/main">
   <p:cSld>
     <p:bg>
       <p:bgPr>
@@ -5920,7 +6163,14 @@
         <p:cNvGrpSpPr/>
         <p:nvPr/>
       </p:nvGrpSpPr>
-      <p:grpSpPr/>
+      <p:grpSpPr>
+        <a:xfrm>
+          <a:off x="0" y="0"/>
+          <a:ext cx="0" cy="0"/>
+          <a:chOff x="0" y="0"/>
+          <a:chExt cx="0" cy="0"/>
+        </a:xfrm>
+      </p:grpSpPr>
       <p:sp>
         <p:nvSpPr>
           <p:cNvPr id="2" name="TextBox 1"/>
@@ -5998,6 +6248,7 @@
           <a:lstStyle/>
           <a:p>
             <a:pPr algn="ctr"/>
+            <a:endParaRPr/>
           </a:p>
         </p:txBody>
       </p:sp>
@@ -6138,6 +6389,7 @@
           <a:lstStyle/>
           <a:p>
             <a:pPr algn="ctr"/>
+            <a:endParaRPr/>
           </a:p>
         </p:txBody>
       </p:sp>
@@ -6278,6 +6530,7 @@
           <a:lstStyle/>
           <a:p>
             <a:pPr algn="ctr"/>
+            <a:endParaRPr/>
           </a:p>
         </p:txBody>
       </p:sp>
@@ -6418,6 +6671,7 @@
           <a:lstStyle/>
           <a:p>
             <a:pPr algn="ctr"/>
+            <a:endParaRPr/>
           </a:p>
         </p:txBody>
       </p:sp>
@@ -6558,6 +6812,7 @@
           <a:lstStyle/>
           <a:p>
             <a:pPr algn="ctr"/>
+            <a:endParaRPr/>
           </a:p>
         </p:txBody>
       </p:sp>
@@ -6728,6 +6983,7 @@
           <a:lstStyle/>
           <a:p>
             <a:pPr algn="ctr"/>
+            <a:endParaRPr/>
           </a:p>
         </p:txBody>
       </p:sp>
@@ -6835,7 +7091,470 @@
 </file>
 
 <file path=ppt/slides/slide16.xml><?xml version="1.0" encoding="utf-8"?>
-<p:sld xmlns:a="http://schemas.openxmlformats.org/drawingml/2006/main" xmlns:p="http://schemas.openxmlformats.org/presentationml/2006/main" xmlns:r="http://schemas.openxmlformats.org/officeDocument/2006/relationships">
+<p:sld xmlns:a="http://schemas.openxmlformats.org/drawingml/2006/main" xmlns:r="http://schemas.openxmlformats.org/officeDocument/2006/relationships" xmlns:p="http://schemas.openxmlformats.org/presentationml/2006/main">
+  <p:cSld>
+    <p:bg>
+      <p:bgPr>
+        <a:solidFill>
+          <a:srgbClr val="1A1A2E"/>
+        </a:solidFill>
+        <a:effectLst/>
+      </p:bgPr>
+    </p:bg>
+    <p:spTree>
+      <p:nvGrpSpPr>
+        <p:cNvPr id="1" name="">
+          <a:extLst>
+            <a:ext uri="{FF2B5EF4-FFF2-40B4-BE49-F238E27FC236}">
+              <a16:creationId xmlns:a16="http://schemas.microsoft.com/office/drawing/2014/main" id="{0694AEAF-32ED-21B2-E4D8-472DBBE5B6B3}"/>
+            </a:ext>
+          </a:extLst>
+        </p:cNvPr>
+        <p:cNvGrpSpPr/>
+        <p:nvPr/>
+      </p:nvGrpSpPr>
+      <p:grpSpPr>
+        <a:xfrm>
+          <a:off x="0" y="0"/>
+          <a:ext cx="0" cy="0"/>
+          <a:chOff x="0" y="0"/>
+          <a:chExt cx="0" cy="0"/>
+        </a:xfrm>
+      </p:grpSpPr>
+      <p:sp>
+        <p:nvSpPr>
+          <p:cNvPr id="2" name="TextBox 1">
+            <a:extLst>
+              <a:ext uri="{FF2B5EF4-FFF2-40B4-BE49-F238E27FC236}">
+                <a16:creationId xmlns:a16="http://schemas.microsoft.com/office/drawing/2014/main" id="{4466F37E-EDCB-6CF3-ABD3-A72E4B5ECCAC}"/>
+              </a:ext>
+            </a:extLst>
+          </p:cNvPr>
+          <p:cNvSpPr txBox="1"/>
+          <p:nvPr/>
+        </p:nvSpPr>
+        <p:spPr>
+          <a:xfrm>
+            <a:off x="640080" y="457200"/>
+            <a:ext cx="10972800" cy="646331"/>
+          </a:xfrm>
+          <a:prstGeom prst="rect">
+            <a:avLst/>
+          </a:prstGeom>
+          <a:noFill/>
+        </p:spPr>
+        <p:txBody>
+          <a:bodyPr wrap="square">
+            <a:spAutoFit/>
+          </a:bodyPr>
+          <a:lstStyle/>
+          <a:p>
+            <a:pPr marL="0" marR="0" lvl="0" indent="0" algn="l" defTabSz="457200" rtl="0" eaLnBrk="1" fontAlgn="auto" latinLnBrk="0" hangingPunct="1">
+              <a:lnSpc>
+                <a:spcPct val="100000"/>
+              </a:lnSpc>
+              <a:spcBef>
+                <a:spcPts val="0"/>
+              </a:spcBef>
+              <a:spcAft>
+                <a:spcPts val="0"/>
+              </a:spcAft>
+              <a:buClrTx/>
+              <a:buSzTx/>
+              <a:buFontTx/>
+              <a:buNone/>
+              <a:tabLst/>
+              <a:defRPr sz="3600" b="1">
+                <a:solidFill>
+                  <a:srgbClr val="00D4AA"/>
+                </a:solidFill>
+              </a:defRPr>
+            </a:pPr>
+            <a:r>
+              <a:rPr lang="en-US" sz="3600" b="1" dirty="0">
+                <a:solidFill>
+                  <a:srgbClr val="00D4AA"/>
+                </a:solidFill>
+                <a:latin typeface="Calibri"/>
+              </a:rPr>
+              <a:t>Policy RAG</a:t>
+            </a:r>
+            <a:endParaRPr kumimoji="0" sz="3600" b="1" i="0" u="none" strike="noStrike" kern="1200" cap="none" spc="0" normalizeH="0" baseline="0" noProof="0" dirty="0">
+              <a:ln>
+                <a:noFill/>
+              </a:ln>
+              <a:solidFill>
+                <a:srgbClr val="00D4AA"/>
+              </a:solidFill>
+              <a:effectLst/>
+              <a:uLnTx/>
+              <a:uFillTx/>
+              <a:latin typeface="Calibri"/>
+              <a:ea typeface="+mn-ea"/>
+              <a:cs typeface="+mn-cs"/>
+            </a:endParaRPr>
+          </a:p>
+        </p:txBody>
+      </p:sp>
+      <p:pic>
+        <p:nvPicPr>
+          <p:cNvPr id="4" name="Picture 3">
+            <a:extLst>
+              <a:ext uri="{FF2B5EF4-FFF2-40B4-BE49-F238E27FC236}">
+                <a16:creationId xmlns:a16="http://schemas.microsoft.com/office/drawing/2014/main" id="{C175107C-1D1E-5014-89A0-43756BE15A32}"/>
+              </a:ext>
+            </a:extLst>
+          </p:cNvPr>
+          <p:cNvPicPr>
+            <a:picLocks noChangeAspect="1"/>
+          </p:cNvPicPr>
+          <p:nvPr/>
+        </p:nvPicPr>
+        <p:blipFill>
+          <a:blip r:embed="rId2"/>
+          <a:stretch>
+            <a:fillRect/>
+          </a:stretch>
+        </p:blipFill>
+        <p:spPr>
+          <a:xfrm>
+            <a:off x="302585" y="2435843"/>
+            <a:ext cx="11586830" cy="1986313"/>
+          </a:xfrm>
+          <a:prstGeom prst="rect">
+            <a:avLst/>
+          </a:prstGeom>
+        </p:spPr>
+      </p:pic>
+    </p:spTree>
+    <p:extLst>
+      <p:ext uri="{BB962C8B-B14F-4D97-AF65-F5344CB8AC3E}">
+        <p14:creationId xmlns:p14="http://schemas.microsoft.com/office/powerpoint/2010/main" val="2513471557"/>
+      </p:ext>
+    </p:extLst>
+  </p:cSld>
+  <p:clrMapOvr>
+    <a:masterClrMapping/>
+  </p:clrMapOvr>
+</p:sld>
+</file>
+
+<file path=ppt/slides/slide17.xml><?xml version="1.0" encoding="utf-8"?>
+<p:sld xmlns:a="http://schemas.openxmlformats.org/drawingml/2006/main" xmlns:r="http://schemas.openxmlformats.org/officeDocument/2006/relationships" xmlns:p="http://schemas.openxmlformats.org/presentationml/2006/main">
+  <p:cSld>
+    <p:bg>
+      <p:bgPr>
+        <a:solidFill>
+          <a:srgbClr val="1A1A2E"/>
+        </a:solidFill>
+        <a:effectLst/>
+      </p:bgPr>
+    </p:bg>
+    <p:spTree>
+      <p:nvGrpSpPr>
+        <p:cNvPr id="1" name="">
+          <a:extLst>
+            <a:ext uri="{FF2B5EF4-FFF2-40B4-BE49-F238E27FC236}">
+              <a16:creationId xmlns:a16="http://schemas.microsoft.com/office/drawing/2014/main" id="{1BAB7264-B3D6-0BF7-CAA7-77C06C3AAA61}"/>
+            </a:ext>
+          </a:extLst>
+        </p:cNvPr>
+        <p:cNvGrpSpPr/>
+        <p:nvPr/>
+      </p:nvGrpSpPr>
+      <p:grpSpPr>
+        <a:xfrm>
+          <a:off x="0" y="0"/>
+          <a:ext cx="0" cy="0"/>
+          <a:chOff x="0" y="0"/>
+          <a:chExt cx="0" cy="0"/>
+        </a:xfrm>
+      </p:grpSpPr>
+      <p:sp>
+        <p:nvSpPr>
+          <p:cNvPr id="2" name="TextBox 1">
+            <a:extLst>
+              <a:ext uri="{FF2B5EF4-FFF2-40B4-BE49-F238E27FC236}">
+                <a16:creationId xmlns:a16="http://schemas.microsoft.com/office/drawing/2014/main" id="{3275E180-F0BC-4AA9-BDD5-7D5F55875762}"/>
+              </a:ext>
+            </a:extLst>
+          </p:cNvPr>
+          <p:cNvSpPr txBox="1"/>
+          <p:nvPr/>
+        </p:nvSpPr>
+        <p:spPr>
+          <a:xfrm>
+            <a:off x="640080" y="457200"/>
+            <a:ext cx="10972800" cy="646331"/>
+          </a:xfrm>
+          <a:prstGeom prst="rect">
+            <a:avLst/>
+          </a:prstGeom>
+          <a:noFill/>
+        </p:spPr>
+        <p:txBody>
+          <a:bodyPr wrap="square">
+            <a:spAutoFit/>
+          </a:bodyPr>
+          <a:lstStyle/>
+          <a:p>
+            <a:pPr marL="0" marR="0" lvl="0" indent="0" algn="l" defTabSz="457200" rtl="0" eaLnBrk="1" fontAlgn="auto" latinLnBrk="0" hangingPunct="1">
+              <a:lnSpc>
+                <a:spcPct val="100000"/>
+              </a:lnSpc>
+              <a:spcBef>
+                <a:spcPts val="0"/>
+              </a:spcBef>
+              <a:spcAft>
+                <a:spcPts val="0"/>
+              </a:spcAft>
+              <a:buClrTx/>
+              <a:buSzTx/>
+              <a:buFontTx/>
+              <a:buNone/>
+              <a:tabLst/>
+              <a:defRPr sz="3600" b="1">
+                <a:solidFill>
+                  <a:srgbClr val="00D4AA"/>
+                </a:solidFill>
+              </a:defRPr>
+            </a:pPr>
+            <a:r>
+              <a:rPr kumimoji="0" lang="en-US" sz="3600" b="1" i="0" u="none" strike="noStrike" kern="1200" cap="none" spc="0" normalizeH="0" baseline="0" noProof="0" dirty="0">
+                <a:ln>
+                  <a:noFill/>
+                </a:ln>
+                <a:solidFill>
+                  <a:srgbClr val="00D4AA"/>
+                </a:solidFill>
+                <a:effectLst/>
+                <a:uLnTx/>
+                <a:uFillTx/>
+                <a:latin typeface="Calibri"/>
+                <a:ea typeface="+mn-ea"/>
+                <a:cs typeface="+mn-cs"/>
+              </a:rPr>
+              <a:t>Policy Evaluation</a:t>
+            </a:r>
+            <a:endParaRPr kumimoji="0" sz="3600" b="1" i="0" u="none" strike="noStrike" kern="1200" cap="none" spc="0" normalizeH="0" baseline="0" noProof="0" dirty="0">
+              <a:ln>
+                <a:noFill/>
+              </a:ln>
+              <a:solidFill>
+                <a:srgbClr val="00D4AA"/>
+              </a:solidFill>
+              <a:effectLst/>
+              <a:uLnTx/>
+              <a:uFillTx/>
+              <a:latin typeface="Calibri"/>
+              <a:ea typeface="+mn-ea"/>
+              <a:cs typeface="+mn-cs"/>
+            </a:endParaRPr>
+          </a:p>
+        </p:txBody>
+      </p:sp>
+      <p:pic>
+        <p:nvPicPr>
+          <p:cNvPr id="5" name="Picture 4">
+            <a:extLst>
+              <a:ext uri="{FF2B5EF4-FFF2-40B4-BE49-F238E27FC236}">
+                <a16:creationId xmlns:a16="http://schemas.microsoft.com/office/drawing/2014/main" id="{F7B0C30E-8580-2199-F01D-5FDD4F36A198}"/>
+              </a:ext>
+            </a:extLst>
+          </p:cNvPr>
+          <p:cNvPicPr>
+            <a:picLocks noChangeAspect="1"/>
+          </p:cNvPicPr>
+          <p:nvPr/>
+        </p:nvPicPr>
+        <p:blipFill>
+          <a:blip r:embed="rId2"/>
+          <a:stretch>
+            <a:fillRect/>
+          </a:stretch>
+        </p:blipFill>
+        <p:spPr>
+          <a:xfrm>
+            <a:off x="640080" y="2295790"/>
+            <a:ext cx="10411717" cy="2834456"/>
+          </a:xfrm>
+          <a:prstGeom prst="rect">
+            <a:avLst/>
+          </a:prstGeom>
+        </p:spPr>
+      </p:pic>
+    </p:spTree>
+    <p:extLst>
+      <p:ext uri="{BB962C8B-B14F-4D97-AF65-F5344CB8AC3E}">
+        <p14:creationId xmlns:p14="http://schemas.microsoft.com/office/powerpoint/2010/main" val="958718457"/>
+      </p:ext>
+    </p:extLst>
+  </p:cSld>
+  <p:clrMapOvr>
+    <a:masterClrMapping/>
+  </p:clrMapOvr>
+</p:sld>
+</file>
+
+<file path=ppt/slides/slide18.xml><?xml version="1.0" encoding="utf-8"?>
+<p:sld xmlns:a="http://schemas.openxmlformats.org/drawingml/2006/main" xmlns:r="http://schemas.openxmlformats.org/officeDocument/2006/relationships" xmlns:p="http://schemas.openxmlformats.org/presentationml/2006/main">
+  <p:cSld>
+    <p:bg>
+      <p:bgPr>
+        <a:solidFill>
+          <a:srgbClr val="1A1A2E"/>
+        </a:solidFill>
+        <a:effectLst/>
+      </p:bgPr>
+    </p:bg>
+    <p:spTree>
+      <p:nvGrpSpPr>
+        <p:cNvPr id="1" name="">
+          <a:extLst>
+            <a:ext uri="{FF2B5EF4-FFF2-40B4-BE49-F238E27FC236}">
+              <a16:creationId xmlns:a16="http://schemas.microsoft.com/office/drawing/2014/main" id="{BF2BF646-724E-29DE-D1C0-1BC1E736DB44}"/>
+            </a:ext>
+          </a:extLst>
+        </p:cNvPr>
+        <p:cNvGrpSpPr/>
+        <p:nvPr/>
+      </p:nvGrpSpPr>
+      <p:grpSpPr>
+        <a:xfrm>
+          <a:off x="0" y="0"/>
+          <a:ext cx="0" cy="0"/>
+          <a:chOff x="0" y="0"/>
+          <a:chExt cx="0" cy="0"/>
+        </a:xfrm>
+      </p:grpSpPr>
+      <p:sp>
+        <p:nvSpPr>
+          <p:cNvPr id="2" name="TextBox 1">
+            <a:extLst>
+              <a:ext uri="{FF2B5EF4-FFF2-40B4-BE49-F238E27FC236}">
+                <a16:creationId xmlns:a16="http://schemas.microsoft.com/office/drawing/2014/main" id="{F8042289-4741-DD30-6C61-1A1DBC18A5B3}"/>
+              </a:ext>
+            </a:extLst>
+          </p:cNvPr>
+          <p:cNvSpPr txBox="1"/>
+          <p:nvPr/>
+        </p:nvSpPr>
+        <p:spPr>
+          <a:xfrm>
+            <a:off x="640080" y="457200"/>
+            <a:ext cx="10972800" cy="646331"/>
+          </a:xfrm>
+          <a:prstGeom prst="rect">
+            <a:avLst/>
+          </a:prstGeom>
+          <a:noFill/>
+        </p:spPr>
+        <p:txBody>
+          <a:bodyPr wrap="square">
+            <a:spAutoFit/>
+          </a:bodyPr>
+          <a:lstStyle/>
+          <a:p>
+            <a:pPr marL="0" marR="0" lvl="0" indent="0" algn="l" defTabSz="457200" rtl="0" eaLnBrk="1" fontAlgn="auto" latinLnBrk="0" hangingPunct="1">
+              <a:lnSpc>
+                <a:spcPct val="100000"/>
+              </a:lnSpc>
+              <a:spcBef>
+                <a:spcPts val="0"/>
+              </a:spcBef>
+              <a:spcAft>
+                <a:spcPts val="0"/>
+              </a:spcAft>
+              <a:buClrTx/>
+              <a:buSzTx/>
+              <a:buFontTx/>
+              <a:buNone/>
+              <a:tabLst/>
+              <a:defRPr sz="3600" b="1">
+                <a:solidFill>
+                  <a:srgbClr val="00D4AA"/>
+                </a:solidFill>
+              </a:defRPr>
+            </a:pPr>
+            <a:r>
+              <a:rPr kumimoji="0" lang="en-US" sz="3600" b="1" i="0" u="none" strike="noStrike" kern="1200" cap="none" spc="0" normalizeH="0" baseline="0" noProof="0" dirty="0">
+                <a:ln>
+                  <a:noFill/>
+                </a:ln>
+                <a:solidFill>
+                  <a:srgbClr val="00D4AA"/>
+                </a:solidFill>
+                <a:effectLst/>
+                <a:uLnTx/>
+                <a:uFillTx/>
+                <a:latin typeface="Calibri"/>
+                <a:ea typeface="+mn-ea"/>
+                <a:cs typeface="+mn-cs"/>
+              </a:rPr>
+              <a:t>Evidence Evaluation</a:t>
+            </a:r>
+            <a:endParaRPr kumimoji="0" sz="3600" b="1" i="0" u="none" strike="noStrike" kern="1200" cap="none" spc="0" normalizeH="0" baseline="0" noProof="0" dirty="0">
+              <a:ln>
+                <a:noFill/>
+              </a:ln>
+              <a:solidFill>
+                <a:srgbClr val="00D4AA"/>
+              </a:solidFill>
+              <a:effectLst/>
+              <a:uLnTx/>
+              <a:uFillTx/>
+              <a:latin typeface="Calibri"/>
+              <a:ea typeface="+mn-ea"/>
+              <a:cs typeface="+mn-cs"/>
+            </a:endParaRPr>
+          </a:p>
+        </p:txBody>
+      </p:sp>
+      <p:pic>
+        <p:nvPicPr>
+          <p:cNvPr id="6" name="Picture 5">
+            <a:extLst>
+              <a:ext uri="{FF2B5EF4-FFF2-40B4-BE49-F238E27FC236}">
+                <a16:creationId xmlns:a16="http://schemas.microsoft.com/office/drawing/2014/main" id="{FA1A44BC-9BDA-CF25-8298-950578E964DF}"/>
+              </a:ext>
+            </a:extLst>
+          </p:cNvPr>
+          <p:cNvPicPr>
+            <a:picLocks noChangeAspect="1"/>
+          </p:cNvPicPr>
+          <p:nvPr/>
+        </p:nvPicPr>
+        <p:blipFill>
+          <a:blip r:embed="rId2"/>
+          <a:stretch>
+            <a:fillRect/>
+          </a:stretch>
+        </p:blipFill>
+        <p:spPr>
+          <a:xfrm>
+            <a:off x="590461" y="2051786"/>
+            <a:ext cx="10519355" cy="3126270"/>
+          </a:xfrm>
+          <a:prstGeom prst="rect">
+            <a:avLst/>
+          </a:prstGeom>
+        </p:spPr>
+      </p:pic>
+    </p:spTree>
+    <p:extLst>
+      <p:ext uri="{BB962C8B-B14F-4D97-AF65-F5344CB8AC3E}">
+        <p14:creationId xmlns:p14="http://schemas.microsoft.com/office/powerpoint/2010/main" val="2259626374"/>
+      </p:ext>
+    </p:extLst>
+  </p:cSld>
+  <p:clrMapOvr>
+    <a:masterClrMapping/>
+  </p:clrMapOvr>
+</p:sld>
+</file>
+
+<file path=ppt/slides/slide19.xml><?xml version="1.0" encoding="utf-8"?>
+<p:sld xmlns:a="http://schemas.openxmlformats.org/drawingml/2006/main" xmlns:r="http://schemas.openxmlformats.org/officeDocument/2006/relationships" xmlns:p="http://schemas.openxmlformats.org/presentationml/2006/main">
   <p:cSld>
     <p:bg>
       <p:bgPr>
@@ -6851,7 +7570,14 @@
         <p:cNvGrpSpPr/>
         <p:nvPr/>
       </p:nvGrpSpPr>
-      <p:grpSpPr/>
+      <p:grpSpPr>
+        <a:xfrm>
+          <a:off x="0" y="0"/>
+          <a:ext cx="0" cy="0"/>
+          <a:chOff x="0" y="0"/>
+          <a:chExt cx="0" cy="0"/>
+        </a:xfrm>
+      </p:grpSpPr>
       <p:sp>
         <p:nvSpPr>
           <p:cNvPr id="2" name="TextBox 1"/>
@@ -6861,7 +7587,7 @@
         <p:spPr>
           <a:xfrm>
             <a:off x="640080" y="457200"/>
-            <a:ext cx="10972800" cy="762000"/>
+            <a:ext cx="10972800" cy="646331"/>
           </a:xfrm>
           <a:prstGeom prst="rect">
             <a:avLst/>
@@ -6882,1178 +7608,43 @@
               </a:defRPr>
             </a:pPr>
             <a:r>
-              <a:t>Architecture: Fully On-Premises (Air-Gapped)</a:t>
-            </a:r>
-          </a:p>
-        </p:txBody>
-      </p:sp>
-      <p:sp>
-        <p:nvSpPr>
-          <p:cNvPr id="3" name="Rounded Rectangle 2"/>
-          <p:cNvSpPr/>
+              <a:rPr lang="en-US" dirty="0"/>
+              <a:t>Agent to Agent Communication</a:t>
+            </a:r>
+            <a:endParaRPr dirty="0"/>
+          </a:p>
+        </p:txBody>
+      </p:sp>
+      <p:pic>
+        <p:nvPicPr>
+          <p:cNvPr id="16" name="Picture 15">
+            <a:extLst>
+              <a:ext uri="{FF2B5EF4-FFF2-40B4-BE49-F238E27FC236}">
+                <a16:creationId xmlns:a16="http://schemas.microsoft.com/office/drawing/2014/main" id="{9A736638-BA6F-F3F9-2C63-9DF8F8E131C4}"/>
+              </a:ext>
+            </a:extLst>
+          </p:cNvPr>
+          <p:cNvPicPr>
+            <a:picLocks noChangeAspect="1"/>
+          </p:cNvPicPr>
           <p:nvPr/>
-        </p:nvSpPr>
+        </p:nvPicPr>
+        <p:blipFill>
+          <a:blip r:embed="rId2"/>
+          <a:stretch>
+            <a:fillRect/>
+          </a:stretch>
+        </p:blipFill>
         <p:spPr>
           <a:xfrm>
-            <a:off x="274320" y="1371600"/>
-            <a:ext cx="2743200" cy="2286000"/>
-          </a:xfrm>
-          <a:prstGeom prst="roundRect">
-            <a:avLst/>
-          </a:prstGeom>
-          <a:solidFill>
-            <a:srgbClr val="16213E"/>
-          </a:solidFill>
-          <a:ln w="12700">
-            <a:solidFill>
-              <a:srgbClr val="00D4AA"/>
-            </a:solidFill>
-          </a:ln>
-        </p:spPr>
-        <p:style>
-          <a:lnRef idx="1">
-            <a:schemeClr val="accent1"/>
-          </a:lnRef>
-          <a:fillRef idx="3">
-            <a:schemeClr val="accent1"/>
-          </a:fillRef>
-          <a:effectRef idx="2">
-            <a:schemeClr val="accent1"/>
-          </a:effectRef>
-          <a:fontRef idx="minor">
-            <a:schemeClr val="lt1"/>
-          </a:fontRef>
-        </p:style>
-        <p:txBody>
-          <a:bodyPr rtlCol="0" anchor="ctr"/>
-          <a:lstStyle/>
-          <a:p>
-            <a:pPr algn="ctr"/>
-          </a:p>
-        </p:txBody>
-      </p:sp>
-      <p:sp>
-        <p:nvSpPr>
-          <p:cNvPr id="4" name="TextBox 3"/>
-          <p:cNvSpPr txBox="1"/>
-          <p:nvPr/>
-        </p:nvSpPr>
-        <p:spPr>
-          <a:xfrm>
-            <a:off x="411480" y="1463040"/>
-            <a:ext cx="2468880" cy="2103120"/>
+            <a:off x="382020" y="1467044"/>
+            <a:ext cx="11427960" cy="4933756"/>
           </a:xfrm>
           <a:prstGeom prst="rect">
             <a:avLst/>
           </a:prstGeom>
-          <a:noFill/>
         </p:spPr>
-        <p:txBody>
-          <a:bodyPr wrap="square">
-            <a:spAutoFit/>
-          </a:bodyPr>
-          <a:lstStyle/>
-          <a:p>
-            <a:pPr>
-              <a:defRPr sz="1200" b="1">
-                <a:solidFill>
-                  <a:srgbClr val="00D4AA"/>
-                </a:solidFill>
-              </a:defRPr>
-            </a:pPr>
-            <a:r>
-              <a:t>IDENTITY</a:t>
-            </a:r>
-          </a:p>
-          <a:p>
-            <a:pPr>
-              <a:spcBef>
-                <a:spcPts val="200"/>
-              </a:spcBef>
-              <a:defRPr sz="1100">
-                <a:solidFill>
-                  <a:srgbClr val="EAEAEA"/>
-                </a:solidFill>
-              </a:defRPr>
-            </a:pPr>
-            <a:r>
-              <a:t>Active Directory / LDAP</a:t>
-            </a:r>
-          </a:p>
-          <a:p>
-            <a:pPr>
-              <a:spcBef>
-                <a:spcPts val="200"/>
-              </a:spcBef>
-              <a:defRPr sz="1100">
-                <a:solidFill>
-                  <a:srgbClr val="EAEAEA"/>
-                </a:solidFill>
-              </a:defRPr>
-            </a:pPr>
-            <a:r>
-              <a:t>Keycloak (OIDC/SAML)</a:t>
-            </a:r>
-          </a:p>
-          <a:p>
-            <a:pPr>
-              <a:spcBef>
-                <a:spcPts val="200"/>
-              </a:spcBef>
-              <a:defRPr sz="1100">
-                <a:solidFill>
-                  <a:srgbClr val="EAEAEA"/>
-                </a:solidFill>
-              </a:defRPr>
-            </a:pPr>
-            <a:r>
-              <a:t>HashiCorp Vault (secrets)</a:t>
-            </a:r>
-          </a:p>
-          <a:p>
-            <a:pPr>
-              <a:spcBef>
-                <a:spcPts val="200"/>
-              </a:spcBef>
-              <a:defRPr sz="1100">
-                <a:solidFill>
-                  <a:srgbClr val="EAEAEA"/>
-                </a:solidFill>
-              </a:defRPr>
-            </a:pPr>
-            <a:r>
-              <a:t>Internal CA (mTLS)</a:t>
-            </a:r>
-          </a:p>
-        </p:txBody>
-      </p:sp>
-      <p:sp>
-        <p:nvSpPr>
-          <p:cNvPr id="5" name="Rounded Rectangle 4"/>
-          <p:cNvSpPr/>
-          <p:nvPr/>
-        </p:nvSpPr>
-        <p:spPr>
-          <a:xfrm>
-            <a:off x="3291840" y="1371600"/>
-            <a:ext cx="5029200" cy="2286000"/>
-          </a:xfrm>
-          <a:prstGeom prst="roundRect">
-            <a:avLst/>
-          </a:prstGeom>
-          <a:solidFill>
-            <a:srgbClr val="16213E"/>
-          </a:solidFill>
-          <a:ln w="12700">
-            <a:solidFill>
-              <a:srgbClr val="00D4AA"/>
-            </a:solidFill>
-          </a:ln>
-        </p:spPr>
-        <p:style>
-          <a:lnRef idx="1">
-            <a:schemeClr val="accent1"/>
-          </a:lnRef>
-          <a:fillRef idx="3">
-            <a:schemeClr val="accent1"/>
-          </a:fillRef>
-          <a:effectRef idx="2">
-            <a:schemeClr val="accent1"/>
-          </a:effectRef>
-          <a:fontRef idx="minor">
-            <a:schemeClr val="lt1"/>
-          </a:fontRef>
-        </p:style>
-        <p:txBody>
-          <a:bodyPr rtlCol="0" anchor="ctr"/>
-          <a:lstStyle/>
-          <a:p>
-            <a:pPr algn="ctr"/>
-          </a:p>
-        </p:txBody>
-      </p:sp>
-      <p:sp>
-        <p:nvSpPr>
-          <p:cNvPr id="6" name="TextBox 5"/>
-          <p:cNvSpPr txBox="1"/>
-          <p:nvPr/>
-        </p:nvSpPr>
-        <p:spPr>
-          <a:xfrm>
-            <a:off x="3429000" y="1463040"/>
-            <a:ext cx="4754880" cy="2103120"/>
-          </a:xfrm>
-          <a:prstGeom prst="rect">
-            <a:avLst/>
-          </a:prstGeom>
-          <a:noFill/>
-        </p:spPr>
-        <p:txBody>
-          <a:bodyPr wrap="square">
-            <a:spAutoFit/>
-          </a:bodyPr>
-          <a:lstStyle/>
-          <a:p>
-            <a:pPr>
-              <a:defRPr sz="1200" b="1">
-                <a:solidFill>
-                  <a:srgbClr val="00D4AA"/>
-                </a:solidFill>
-              </a:defRPr>
-            </a:pPr>
-            <a:r>
-              <a:t>DOCKER COMPOSE / K8s (app tier)</a:t>
-            </a:r>
-          </a:p>
-          <a:p>
-            <a:pPr>
-              <a:spcBef>
-                <a:spcPts val="200"/>
-              </a:spcBef>
-              <a:defRPr sz="1100">
-                <a:solidFill>
-                  <a:srgbClr val="EAEAEA"/>
-                </a:solidFill>
-              </a:defRPr>
-            </a:pPr>
-            <a:r>
-              <a:t>llm-gateway → Ollama / vLLM (GPU)</a:t>
-            </a:r>
-          </a:p>
-          <a:p>
-            <a:pPr>
-              <a:spcBef>
-                <a:spcPts val="200"/>
-              </a:spcBef>
-              <a:defRPr sz="1100">
-                <a:solidFill>
-                  <a:srgbClr val="EAEAEA"/>
-                </a:solidFill>
-              </a:defRPr>
-            </a:pPr>
-            <a:r>
-              <a:t>agent-eval | compliance-assistant</a:t>
-            </a:r>
-          </a:p>
-          <a:p>
-            <a:pPr>
-              <a:spcBef>
-                <a:spcPts val="200"/>
-              </a:spcBef>
-              <a:defRPr sz="1100">
-                <a:solidFill>
-                  <a:srgbClr val="EAEAEA"/>
-                </a:solidFill>
-              </a:defRPr>
-            </a:pPr>
-            <a:r>
-              <a:t>memory-svc | observer</a:t>
-            </a:r>
-          </a:p>
-          <a:p>
-            <a:pPr>
-              <a:spcBef>
-                <a:spcPts val="200"/>
-              </a:spcBef>
-              <a:defRPr sz="1100">
-                <a:solidFill>
-                  <a:srgbClr val="EAEAEA"/>
-                </a:solidFill>
-              </a:defRPr>
-            </a:pPr>
-            <a:r>
-              <a:t>preprocessor | sandbox-svc</a:t>
-            </a:r>
-          </a:p>
-        </p:txBody>
-      </p:sp>
-      <p:sp>
-        <p:nvSpPr>
-          <p:cNvPr id="7" name="Rounded Rectangle 6"/>
-          <p:cNvSpPr/>
-          <p:nvPr/>
-        </p:nvSpPr>
-        <p:spPr>
-          <a:xfrm>
-            <a:off x="8595360" y="1371600"/>
-            <a:ext cx="3291840" cy="2286000"/>
-          </a:xfrm>
-          <a:prstGeom prst="roundRect">
-            <a:avLst/>
-          </a:prstGeom>
-          <a:solidFill>
-            <a:srgbClr val="16213E"/>
-          </a:solidFill>
-          <a:ln w="12700">
-            <a:solidFill>
-              <a:srgbClr val="00D4AA"/>
-            </a:solidFill>
-          </a:ln>
-        </p:spPr>
-        <p:style>
-          <a:lnRef idx="1">
-            <a:schemeClr val="accent1"/>
-          </a:lnRef>
-          <a:fillRef idx="3">
-            <a:schemeClr val="accent1"/>
-          </a:fillRef>
-          <a:effectRef idx="2">
-            <a:schemeClr val="accent1"/>
-          </a:effectRef>
-          <a:fontRef idx="minor">
-            <a:schemeClr val="lt1"/>
-          </a:fontRef>
-        </p:style>
-        <p:txBody>
-          <a:bodyPr rtlCol="0" anchor="ctr"/>
-          <a:lstStyle/>
-          <a:p>
-            <a:pPr algn="ctr"/>
-          </a:p>
-        </p:txBody>
-      </p:sp>
-      <p:sp>
-        <p:nvSpPr>
-          <p:cNvPr id="8" name="TextBox 7"/>
-          <p:cNvSpPr txBox="1"/>
-          <p:nvPr/>
-        </p:nvSpPr>
-        <p:spPr>
-          <a:xfrm>
-            <a:off x="8732520" y="1463040"/>
-            <a:ext cx="3017520" cy="2103120"/>
-          </a:xfrm>
-          <a:prstGeom prst="rect">
-            <a:avLst/>
-          </a:prstGeom>
-          <a:noFill/>
-        </p:spPr>
-        <p:txBody>
-          <a:bodyPr wrap="square">
-            <a:spAutoFit/>
-          </a:bodyPr>
-          <a:lstStyle/>
-          <a:p>
-            <a:pPr>
-              <a:defRPr sz="1200" b="1">
-                <a:solidFill>
-                  <a:srgbClr val="00D4AA"/>
-                </a:solidFill>
-              </a:defRPr>
-            </a:pPr>
-            <a:r>
-              <a:t>COMMS (internal only)</a:t>
-            </a:r>
-          </a:p>
-          <a:p>
-            <a:pPr>
-              <a:spcBef>
-                <a:spcPts val="200"/>
-              </a:spcBef>
-              <a:defRPr sz="1100">
-                <a:solidFill>
-                  <a:srgbClr val="EAEAEA"/>
-                </a:solidFill>
-              </a:defRPr>
-            </a:pPr>
-            <a:r>
-              <a:t>Teams (on-prem)</a:t>
-            </a:r>
-          </a:p>
-          <a:p>
-            <a:pPr>
-              <a:spcBef>
-                <a:spcPts val="200"/>
-              </a:spcBef>
-              <a:defRPr sz="1100">
-                <a:solidFill>
-                  <a:srgbClr val="EAEAEA"/>
-                </a:solidFill>
-              </a:defRPr>
-            </a:pPr>
-            <a:r>
-              <a:t>SMTP relay</a:t>
-            </a:r>
-          </a:p>
-          <a:p>
-            <a:pPr>
-              <a:spcBef>
-                <a:spcPts val="200"/>
-              </a:spcBef>
-              <a:defRPr sz="1100">
-                <a:solidFill>
-                  <a:srgbClr val="EAEAEA"/>
-                </a:solidFill>
-              </a:defRPr>
-            </a:pPr>
-            <a:r>
-              <a:t>Mattermost</a:t>
-            </a:r>
-          </a:p>
-          <a:p>
-            <a:pPr>
-              <a:spcBef>
-                <a:spcPts val="200"/>
-              </a:spcBef>
-              <a:defRPr sz="1100">
-                <a:solidFill>
-                  <a:srgbClr val="EAEAEA"/>
-                </a:solidFill>
-              </a:defRPr>
-            </a:pPr>
-            <a:r>
-              <a:t>Cisco Webex</a:t>
-            </a:r>
-          </a:p>
-        </p:txBody>
-      </p:sp>
-      <p:sp>
-        <p:nvSpPr>
-          <p:cNvPr id="9" name="Rounded Rectangle 8"/>
-          <p:cNvSpPr/>
-          <p:nvPr/>
-        </p:nvSpPr>
-        <p:spPr>
-          <a:xfrm>
-            <a:off x="274320" y="3931920"/>
-            <a:ext cx="2743200" cy="2560320"/>
-          </a:xfrm>
-          <a:prstGeom prst="roundRect">
-            <a:avLst/>
-          </a:prstGeom>
-          <a:solidFill>
-            <a:srgbClr val="16213E"/>
-          </a:solidFill>
-          <a:ln w="12700">
-            <a:solidFill>
-              <a:srgbClr val="00D4AA"/>
-            </a:solidFill>
-          </a:ln>
-        </p:spPr>
-        <p:style>
-          <a:lnRef idx="1">
-            <a:schemeClr val="accent1"/>
-          </a:lnRef>
-          <a:fillRef idx="3">
-            <a:schemeClr val="accent1"/>
-          </a:fillRef>
-          <a:effectRef idx="2">
-            <a:schemeClr val="accent1"/>
-          </a:effectRef>
-          <a:fontRef idx="minor">
-            <a:schemeClr val="lt1"/>
-          </a:fontRef>
-        </p:style>
-        <p:txBody>
-          <a:bodyPr rtlCol="0" anchor="ctr"/>
-          <a:lstStyle/>
-          <a:p>
-            <a:pPr algn="ctr"/>
-          </a:p>
-        </p:txBody>
-      </p:sp>
-      <p:sp>
-        <p:nvSpPr>
-          <p:cNvPr id="10" name="TextBox 9"/>
-          <p:cNvSpPr txBox="1"/>
-          <p:nvPr/>
-        </p:nvSpPr>
-        <p:spPr>
-          <a:xfrm>
-            <a:off x="411480" y="4023360"/>
-            <a:ext cx="2468880" cy="2377440"/>
-          </a:xfrm>
-          <a:prstGeom prst="rect">
-            <a:avLst/>
-          </a:prstGeom>
-          <a:noFill/>
-        </p:spPr>
-        <p:txBody>
-          <a:bodyPr wrap="square">
-            <a:spAutoFit/>
-          </a:bodyPr>
-          <a:lstStyle/>
-          <a:p>
-            <a:pPr>
-              <a:defRPr sz="1200" b="1">
-                <a:solidFill>
-                  <a:srgbClr val="00D4AA"/>
-                </a:solidFill>
-              </a:defRPr>
-            </a:pPr>
-            <a:r>
-              <a:t>CUSTOMER APPS</a:t>
-            </a:r>
-          </a:p>
-          <a:p>
-            <a:pPr>
-              <a:spcBef>
-                <a:spcPts val="200"/>
-              </a:spcBef>
-              <a:defRPr sz="1100">
-                <a:solidFill>
-                  <a:srgbClr val="EAEAEA"/>
-                </a:solidFill>
-              </a:defRPr>
-            </a:pPr>
-            <a:r>
-              <a:t>Jira Server</a:t>
-            </a:r>
-          </a:p>
-          <a:p>
-            <a:pPr>
-              <a:spcBef>
-                <a:spcPts val="200"/>
-              </a:spcBef>
-              <a:defRPr sz="1100">
-                <a:solidFill>
-                  <a:srgbClr val="EAEAEA"/>
-                </a:solidFill>
-              </a:defRPr>
-            </a:pPr>
-            <a:r>
-              <a:t>ServiceNow (on-prem)</a:t>
-            </a:r>
-          </a:p>
-          <a:p>
-            <a:pPr>
-              <a:spcBef>
-                <a:spcPts val="200"/>
-              </a:spcBef>
-              <a:defRPr sz="1100">
-                <a:solidFill>
-                  <a:srgbClr val="EAEAEA"/>
-                </a:solidFill>
-              </a:defRPr>
-            </a:pPr>
-            <a:r>
-              <a:t>Archer / RSA</a:t>
-            </a:r>
-          </a:p>
-          <a:p>
-            <a:pPr>
-              <a:spcBef>
-                <a:spcPts val="200"/>
-              </a:spcBef>
-              <a:defRPr sz="1100">
-                <a:solidFill>
-                  <a:srgbClr val="EAEAEA"/>
-                </a:solidFill>
-              </a:defRPr>
-            </a:pPr>
-            <a:r>
-              <a:t>SAP GRC</a:t>
-            </a:r>
-          </a:p>
-          <a:p>
-            <a:pPr>
-              <a:spcBef>
-                <a:spcPts val="200"/>
-              </a:spcBef>
-              <a:defRPr sz="1100">
-                <a:solidFill>
-                  <a:srgbClr val="EAEAEA"/>
-                </a:solidFill>
-              </a:defRPr>
-            </a:pPr>
-            <a:r>
-              <a:t>Workday HCM</a:t>
-            </a:r>
-          </a:p>
-        </p:txBody>
-      </p:sp>
-      <p:sp>
-        <p:nvSpPr>
-          <p:cNvPr id="11" name="Rounded Rectangle 10"/>
-          <p:cNvSpPr/>
-          <p:nvPr/>
-        </p:nvSpPr>
-        <p:spPr>
-          <a:xfrm>
-            <a:off x="3291840" y="3931920"/>
-            <a:ext cx="5029200" cy="2560320"/>
-          </a:xfrm>
-          <a:prstGeom prst="roundRect">
-            <a:avLst/>
-          </a:prstGeom>
-          <a:solidFill>
-            <a:srgbClr val="16213E"/>
-          </a:solidFill>
-          <a:ln w="12700">
-            <a:solidFill>
-              <a:srgbClr val="00D4AA"/>
-            </a:solidFill>
-          </a:ln>
-        </p:spPr>
-        <p:style>
-          <a:lnRef idx="1">
-            <a:schemeClr val="accent1"/>
-          </a:lnRef>
-          <a:fillRef idx="3">
-            <a:schemeClr val="accent1"/>
-          </a:fillRef>
-          <a:effectRef idx="2">
-            <a:schemeClr val="accent1"/>
-          </a:effectRef>
-          <a:fontRef idx="minor">
-            <a:schemeClr val="lt1"/>
-          </a:fontRef>
-        </p:style>
-        <p:txBody>
-          <a:bodyPr rtlCol="0" anchor="ctr"/>
-          <a:lstStyle/>
-          <a:p>
-            <a:pPr algn="ctr"/>
-          </a:p>
-        </p:txBody>
-      </p:sp>
-      <p:sp>
-        <p:nvSpPr>
-          <p:cNvPr id="12" name="TextBox 11"/>
-          <p:cNvSpPr txBox="1"/>
-          <p:nvPr/>
-        </p:nvSpPr>
-        <p:spPr>
-          <a:xfrm>
-            <a:off x="3429000" y="4023360"/>
-            <a:ext cx="4754880" cy="2377440"/>
-          </a:xfrm>
-          <a:prstGeom prst="rect">
-            <a:avLst/>
-          </a:prstGeom>
-          <a:noFill/>
-        </p:spPr>
-        <p:txBody>
-          <a:bodyPr wrap="square">
-            <a:spAutoFit/>
-          </a:bodyPr>
-          <a:lstStyle/>
-          <a:p>
-            <a:pPr>
-              <a:defRPr sz="1200" b="1">
-                <a:solidFill>
-                  <a:srgbClr val="00D4AA"/>
-                </a:solidFill>
-              </a:defRPr>
-            </a:pPr>
-            <a:r>
-              <a:t>SELF-HOSTED INFRA</a:t>
-            </a:r>
-          </a:p>
-          <a:p>
-            <a:pPr>
-              <a:spcBef>
-                <a:spcPts val="200"/>
-              </a:spcBef>
-              <a:defRPr sz="1100">
-                <a:solidFill>
-                  <a:srgbClr val="EAEAEA"/>
-                </a:solidFill>
-              </a:defRPr>
-            </a:pPr>
-            <a:r>
-              <a:t>PostgreSQL + pgvector</a:t>
-            </a:r>
-          </a:p>
-          <a:p>
-            <a:pPr>
-              <a:spcBef>
-                <a:spcPts val="200"/>
-              </a:spcBef>
-              <a:defRPr sz="1100">
-                <a:solidFill>
-                  <a:srgbClr val="EAEAEA"/>
-                </a:solidFill>
-              </a:defRPr>
-            </a:pPr>
-            <a:r>
-              <a:t>MinIO (S3-compatible)</a:t>
-            </a:r>
-          </a:p>
-          <a:p>
-            <a:pPr>
-              <a:spcBef>
-                <a:spcPts val="200"/>
-              </a:spcBef>
-              <a:defRPr sz="1100">
-                <a:solidFill>
-                  <a:srgbClr val="EAEAEA"/>
-                </a:solidFill>
-              </a:defRPr>
-            </a:pPr>
-            <a:r>
-              <a:t>Redis</a:t>
-            </a:r>
-          </a:p>
-          <a:p>
-            <a:pPr>
-              <a:spcBef>
-                <a:spcPts val="200"/>
-              </a:spcBef>
-              <a:defRPr sz="1100">
-                <a:solidFill>
-                  <a:srgbClr val="EAEAEA"/>
-                </a:solidFill>
-              </a:defRPr>
-            </a:pPr>
-            <a:r>
-              <a:t>Tesseract (OCR)</a:t>
-            </a:r>
-          </a:p>
-          <a:p>
-            <a:pPr>
-              <a:spcBef>
-                <a:spcPts val="200"/>
-              </a:spcBef>
-              <a:defRPr sz="1100">
-                <a:solidFill>
-                  <a:srgbClr val="EAEAEA"/>
-                </a:solidFill>
-              </a:defRPr>
-            </a:pPr>
-            <a:r>
-              <a:t>Internal DNS (discovery)</a:t>
-            </a:r>
-          </a:p>
-          <a:p>
-            <a:pPr>
-              <a:spcBef>
-                <a:spcPts val="200"/>
-              </a:spcBef>
-              <a:defRPr sz="1100">
-                <a:solidFill>
-                  <a:srgbClr val="EAEAEA"/>
-                </a:solidFill>
-              </a:defRPr>
-            </a:pPr>
-            <a:r>
-              <a:t>Reverse proxy (nginx/HAProxy)</a:t>
-            </a:r>
-          </a:p>
-          <a:p>
-            <a:pPr>
-              <a:spcBef>
-                <a:spcPts val="200"/>
-              </a:spcBef>
-              <a:defRPr sz="1100">
-                <a:solidFill>
-                  <a:srgbClr val="EAEAEA"/>
-                </a:solidFill>
-              </a:defRPr>
-            </a:pPr>
-            <a:r>
-              <a:t>No egress — fully air-gapped</a:t>
-            </a:r>
-          </a:p>
-        </p:txBody>
-      </p:sp>
-      <p:sp>
-        <p:nvSpPr>
-          <p:cNvPr id="13" name="Rounded Rectangle 12"/>
-          <p:cNvSpPr/>
-          <p:nvPr/>
-        </p:nvSpPr>
-        <p:spPr>
-          <a:xfrm>
-            <a:off x="8595360" y="3931920"/>
-            <a:ext cx="3291840" cy="2560320"/>
-          </a:xfrm>
-          <a:prstGeom prst="roundRect">
-            <a:avLst/>
-          </a:prstGeom>
-          <a:solidFill>
-            <a:srgbClr val="16213E"/>
-          </a:solidFill>
-          <a:ln w="12700">
-            <a:solidFill>
-              <a:srgbClr val="00D4AA"/>
-            </a:solidFill>
-          </a:ln>
-        </p:spPr>
-        <p:style>
-          <a:lnRef idx="1">
-            <a:schemeClr val="accent1"/>
-          </a:lnRef>
-          <a:fillRef idx="3">
-            <a:schemeClr val="accent1"/>
-          </a:fillRef>
-          <a:effectRef idx="2">
-            <a:schemeClr val="accent1"/>
-          </a:effectRef>
-          <a:fontRef idx="minor">
-            <a:schemeClr val="lt1"/>
-          </a:fontRef>
-        </p:style>
-        <p:txBody>
-          <a:bodyPr rtlCol="0" anchor="ctr"/>
-          <a:lstStyle/>
-          <a:p>
-            <a:pPr algn="ctr"/>
-          </a:p>
-        </p:txBody>
-      </p:sp>
-      <p:sp>
-        <p:nvSpPr>
-          <p:cNvPr id="14" name="TextBox 13"/>
-          <p:cNvSpPr txBox="1"/>
-          <p:nvPr/>
-        </p:nvSpPr>
-        <p:spPr>
-          <a:xfrm>
-            <a:off x="8732520" y="4023360"/>
-            <a:ext cx="3017520" cy="2377440"/>
-          </a:xfrm>
-          <a:prstGeom prst="rect">
-            <a:avLst/>
-          </a:prstGeom>
-          <a:noFill/>
-        </p:spPr>
-        <p:txBody>
-          <a:bodyPr wrap="square">
-            <a:spAutoFit/>
-          </a:bodyPr>
-          <a:lstStyle/>
-          <a:p>
-            <a:pPr>
-              <a:defRPr sz="1200" b="1">
-                <a:solidFill>
-                  <a:srgbClr val="00D4AA"/>
-                </a:solidFill>
-              </a:defRPr>
-            </a:pPr>
-            <a:r>
-              <a:t>FILE STORAGE</a:t>
-            </a:r>
-          </a:p>
-          <a:p>
-            <a:pPr>
-              <a:spcBef>
-                <a:spcPts val="200"/>
-              </a:spcBef>
-              <a:defRPr sz="1100">
-                <a:solidFill>
-                  <a:srgbClr val="EAEAEA"/>
-                </a:solidFill>
-              </a:defRPr>
-            </a:pPr>
-            <a:r>
-              <a:t>NFS / CIFS shares</a:t>
-            </a:r>
-          </a:p>
-          <a:p>
-            <a:pPr>
-              <a:spcBef>
-                <a:spcPts val="200"/>
-              </a:spcBef>
-              <a:defRPr sz="1100">
-                <a:solidFill>
-                  <a:srgbClr val="EAEAEA"/>
-                </a:solidFill>
-              </a:defRPr>
-            </a:pPr>
-            <a:r>
-              <a:t>SharePoint (on-prem)</a:t>
-            </a:r>
-          </a:p>
-          <a:p>
-            <a:pPr>
-              <a:spcBef>
-                <a:spcPts val="200"/>
-              </a:spcBef>
-              <a:defRPr sz="1100">
-                <a:solidFill>
-                  <a:srgbClr val="EAEAEA"/>
-                </a:solidFill>
-              </a:defRPr>
-            </a:pPr>
-            <a:r>
-              <a:t>Documentum</a:t>
-            </a:r>
-          </a:p>
-          <a:p>
-            <a:pPr>
-              <a:spcBef>
-                <a:spcPts val="200"/>
-              </a:spcBef>
-              <a:defRPr sz="1100">
-                <a:solidFill>
-                  <a:srgbClr val="EAEAEA"/>
-                </a:solidFill>
-              </a:defRPr>
-            </a:pPr>
-            <a:r>
-              <a:t>Network drives</a:t>
-            </a:r>
-          </a:p>
-        </p:txBody>
-      </p:sp>
-    </p:spTree>
-  </p:cSld>
-  <p:clrMapOvr>
-    <a:masterClrMapping/>
-  </p:clrMapOvr>
-</p:sld>
-</file>
-
-<file path=ppt/slides/slide17.xml><?xml version="1.0" encoding="utf-8"?>
-<p:sld xmlns:a="http://schemas.openxmlformats.org/drawingml/2006/main" xmlns:p="http://schemas.openxmlformats.org/presentationml/2006/main" xmlns:r="http://schemas.openxmlformats.org/officeDocument/2006/relationships">
-  <p:cSld>
-    <p:bg>
-      <p:bgPr>
-        <a:solidFill>
-          <a:srgbClr val="0F0F23"/>
-        </a:solidFill>
-        <a:effectLst/>
-      </p:bgPr>
-    </p:bg>
-    <p:spTree>
-      <p:nvGrpSpPr>
-        <p:cNvPr id="1" name=""/>
-        <p:cNvGrpSpPr/>
-        <p:nvPr/>
-      </p:nvGrpSpPr>
-      <p:grpSpPr/>
-      <p:sp>
-        <p:nvSpPr>
-          <p:cNvPr id="2" name="TextBox 1"/>
-          <p:cNvSpPr txBox="1"/>
-          <p:nvPr/>
-        </p:nvSpPr>
-        <p:spPr>
-          <a:xfrm>
-            <a:off x="640080" y="1371600"/>
-            <a:ext cx="10972800" cy="762000"/>
-          </a:xfrm>
-          <a:prstGeom prst="rect">
-            <a:avLst/>
-          </a:prstGeom>
-          <a:noFill/>
-        </p:spPr>
-        <p:txBody>
-          <a:bodyPr wrap="square">
-            <a:spAutoFit/>
-          </a:bodyPr>
-          <a:lstStyle/>
-          <a:p>
-            <a:pPr>
-              <a:defRPr sz="4000" b="1">
-                <a:solidFill>
-                  <a:srgbClr val="00D4AA"/>
-                </a:solidFill>
-              </a:defRPr>
-            </a:pPr>
-            <a:r>
-              <a:t>The Vision</a:t>
-            </a:r>
-          </a:p>
-        </p:txBody>
-      </p:sp>
-      <p:sp>
-        <p:nvSpPr>
-          <p:cNvPr id="3" name="TextBox 2"/>
-          <p:cNvSpPr txBox="1"/>
-          <p:nvPr/>
-        </p:nvSpPr>
-        <p:spPr>
-          <a:xfrm>
-            <a:off x="640080" y="2286000"/>
-            <a:ext cx="10515600" cy="4572000"/>
-          </a:xfrm>
-          <a:prstGeom prst="rect">
-            <a:avLst/>
-          </a:prstGeom>
-          <a:noFill/>
-        </p:spPr>
-        <p:txBody>
-          <a:bodyPr wrap="square">
-            <a:spAutoFit/>
-          </a:bodyPr>
-          <a:lstStyle/>
-          <a:p>
-            <a:pPr>
-              <a:spcAft>
-                <a:spcPts val="800"/>
-              </a:spcAft>
-              <a:defRPr sz="1800">
-                <a:solidFill>
-                  <a:srgbClr val="EAEAEA"/>
-                </a:solidFill>
-              </a:defRPr>
-            </a:pPr>
-            <a:r>
-              <a:t>Today (everyone else):</a:t>
-            </a:r>
-          </a:p>
-          <a:p>
-            <a:pPr>
-              <a:spcAft>
-                <a:spcPts val="800"/>
-              </a:spcAft>
-              <a:defRPr sz="1800">
-                <a:solidFill>
-                  <a:srgbClr val="EAEAEA"/>
-                </a:solidFill>
-              </a:defRPr>
-            </a:pPr>
-            <a:r>
-              <a:t>  Humans do compliance work. Tools help them do it faster.</a:t>
-            </a:r>
-          </a:p>
-          <a:p>
-            <a:pPr>
-              <a:spcAft>
-                <a:spcPts val="800"/>
-              </a:spcAft>
-              <a:defRPr sz="1800">
-                <a:solidFill>
-                  <a:srgbClr val="EAEAEA"/>
-                </a:solidFill>
-              </a:defRPr>
-            </a:pPr>
-          </a:p>
-          <a:p>
-            <a:pPr>
-              <a:spcAft>
-                <a:spcPts val="800"/>
-              </a:spcAft>
-              <a:defRPr sz="1800">
-                <a:solidFill>
-                  <a:srgbClr val="EAEAEA"/>
-                </a:solidFill>
-              </a:defRPr>
-            </a:pPr>
-            <a:r>
-              <a:t>Tomorrow (us):</a:t>
-            </a:r>
-          </a:p>
-          <a:p>
-            <a:pPr>
-              <a:spcAft>
-                <a:spcPts val="800"/>
-              </a:spcAft>
-              <a:defRPr sz="1800">
-                <a:solidFill>
-                  <a:srgbClr val="EAEAEA"/>
-                </a:solidFill>
-              </a:defRPr>
-            </a:pPr>
-            <a:r>
-              <a:t>  AI agents do compliance work. Humans approve and course-correct.</a:t>
-            </a:r>
-          </a:p>
-          <a:p>
-            <a:pPr>
-              <a:spcAft>
-                <a:spcPts val="800"/>
-              </a:spcAft>
-              <a:defRPr sz="1800">
-                <a:solidFill>
-                  <a:srgbClr val="EAEAEA"/>
-                </a:solidFill>
-              </a:defRPr>
-            </a:pPr>
-          </a:p>
-          <a:p>
-            <a:pPr>
-              <a:spcAft>
-                <a:spcPts val="800"/>
-              </a:spcAft>
-              <a:defRPr sz="1800">
-                <a:solidFill>
-                  <a:srgbClr val="EAEAEA"/>
-                </a:solidFill>
-              </a:defRPr>
-            </a:pPr>
-          </a:p>
-          <a:p>
-            <a:pPr>
-              <a:spcAft>
-                <a:spcPts val="800"/>
-              </a:spcAft>
-              <a:defRPr sz="1800">
-                <a:solidFill>
-                  <a:srgbClr val="EAEAEA"/>
-                </a:solidFill>
-              </a:defRPr>
-            </a:pPr>
-            <a:r>
-              <a:t>The compliance platform disappears.</a:t>
-            </a:r>
-          </a:p>
-          <a:p>
-            <a:pPr>
-              <a:spcAft>
-                <a:spcPts val="800"/>
-              </a:spcAft>
-              <a:defRPr sz="1800">
-                <a:solidFill>
-                  <a:srgbClr val="EAEAEA"/>
-                </a:solidFill>
-              </a:defRPr>
-            </a:pPr>
-            <a:r>
-              <a:t>The agents are the product.</a:t>
-            </a:r>
-          </a:p>
-          <a:p>
-            <a:pPr>
-              <a:spcAft>
-                <a:spcPts val="800"/>
-              </a:spcAft>
-              <a:defRPr sz="1800">
-                <a:solidFill>
-                  <a:srgbClr val="EAEAEA"/>
-                </a:solidFill>
-              </a:defRPr>
-            </a:pPr>
-          </a:p>
-          <a:p>
-            <a:pPr>
-              <a:spcAft>
-                <a:spcPts val="800"/>
-              </a:spcAft>
-              <a:defRPr sz="1800">
-                <a:solidFill>
-                  <a:srgbClr val="EAEAEA"/>
-                </a:solidFill>
-              </a:defRPr>
-            </a:pPr>
-            <a:r>
-              <a:t>Nobody learns a tool. Nobody navigates a dashboard.</a:t>
-            </a:r>
-          </a:p>
-          <a:p>
-            <a:pPr>
-              <a:spcAft>
-                <a:spcPts val="800"/>
-              </a:spcAft>
-              <a:defRPr sz="1800">
-                <a:solidFill>
-                  <a:srgbClr val="EAEAEA"/>
-                </a:solidFill>
-              </a:defRPr>
-            </a:pPr>
-            <a:r>
-              <a:t>Nobody reads a framework document.</a:t>
-            </a:r>
-          </a:p>
-          <a:p>
-            <a:pPr>
-              <a:spcAft>
-                <a:spcPts val="800"/>
-              </a:spcAft>
-              <a:defRPr sz="1800">
-                <a:solidFill>
-                  <a:srgbClr val="EAEAEA"/>
-                </a:solidFill>
-              </a:defRPr>
-            </a:pPr>
-            <a:r>
-              <a:t>The agent handles all of it — and gets better at it every single day.</a:t>
-            </a:r>
-          </a:p>
-        </p:txBody>
-      </p:sp>
+      </p:pic>
     </p:spTree>
   </p:cSld>
   <p:clrMapOvr>
@@ -8063,7 +7654,7 @@
 </file>
 
 <file path=ppt/slides/slide2.xml><?xml version="1.0" encoding="utf-8"?>
-<p:sld xmlns:a="http://schemas.openxmlformats.org/drawingml/2006/main" xmlns:p="http://schemas.openxmlformats.org/presentationml/2006/main" xmlns:r="http://schemas.openxmlformats.org/officeDocument/2006/relationships">
+<p:sld xmlns:a="http://schemas.openxmlformats.org/drawingml/2006/main" xmlns:r="http://schemas.openxmlformats.org/officeDocument/2006/relationships" xmlns:p="http://schemas.openxmlformats.org/presentationml/2006/main">
   <p:cSld>
     <p:bg>
       <p:bgPr>
@@ -8079,7 +7670,14 @@
         <p:cNvGrpSpPr/>
         <p:nvPr/>
       </p:nvGrpSpPr>
-      <p:grpSpPr/>
+      <p:grpSpPr>
+        <a:xfrm>
+          <a:off x="0" y="0"/>
+          <a:ext cx="0" cy="0"/>
+          <a:chOff x="0" y="0"/>
+          <a:chExt cx="0" cy="0"/>
+        </a:xfrm>
+      </p:grpSpPr>
       <p:sp>
         <p:nvSpPr>
           <p:cNvPr id="2" name="TextBox 1"/>
@@ -8257,7 +7855,7 @@
 </file>
 
 <file path=ppt/slides/slide3.xml><?xml version="1.0" encoding="utf-8"?>
-<p:sld xmlns:a="http://schemas.openxmlformats.org/drawingml/2006/main" xmlns:p="http://schemas.openxmlformats.org/presentationml/2006/main" xmlns:r="http://schemas.openxmlformats.org/officeDocument/2006/relationships">
+<p:sld xmlns:a="http://schemas.openxmlformats.org/drawingml/2006/main" xmlns:r="http://schemas.openxmlformats.org/officeDocument/2006/relationships" xmlns:p="http://schemas.openxmlformats.org/presentationml/2006/main">
   <p:cSld>
     <p:bg>
       <p:bgPr>
@@ -8273,7 +7871,14 @@
         <p:cNvGrpSpPr/>
         <p:nvPr/>
       </p:nvGrpSpPr>
-      <p:grpSpPr/>
+      <p:grpSpPr>
+        <a:xfrm>
+          <a:off x="0" y="0"/>
+          <a:ext cx="0" cy="0"/>
+          <a:chOff x="0" y="0"/>
+          <a:chExt cx="0" cy="0"/>
+        </a:xfrm>
+      </p:grpSpPr>
       <p:sp>
         <p:nvSpPr>
           <p:cNvPr id="2" name="TextBox 1"/>
@@ -8391,6 +7996,7 @@
                 </a:solidFill>
               </a:defRPr>
             </a:pPr>
+            <a:endParaRPr/>
           </a:p>
           <a:p>
             <a:pPr>
@@ -8448,6 +8054,7 @@
                 </a:solidFill>
               </a:defRPr>
             </a:pPr>
+            <a:endParaRPr/>
           </a:p>
           <a:p>
             <a:pPr>
@@ -8475,7 +8082,7 @@
 </file>
 
 <file path=ppt/slides/slide4.xml><?xml version="1.0" encoding="utf-8"?>
-<p:sld xmlns:a="http://schemas.openxmlformats.org/drawingml/2006/main" xmlns:p="http://schemas.openxmlformats.org/presentationml/2006/main" xmlns:r="http://schemas.openxmlformats.org/officeDocument/2006/relationships">
+<p:sld xmlns:a="http://schemas.openxmlformats.org/drawingml/2006/main" xmlns:r="http://schemas.openxmlformats.org/officeDocument/2006/relationships" xmlns:p="http://schemas.openxmlformats.org/presentationml/2006/main">
   <p:cSld>
     <p:bg>
       <p:bgPr>
@@ -8491,7 +8098,14 @@
         <p:cNvGrpSpPr/>
         <p:nvPr/>
       </p:nvGrpSpPr>
-      <p:grpSpPr/>
+      <p:grpSpPr>
+        <a:xfrm>
+          <a:off x="0" y="0"/>
+          <a:ext cx="0" cy="0"/>
+          <a:chOff x="0" y="0"/>
+          <a:chExt cx="0" cy="0"/>
+        </a:xfrm>
+      </p:grpSpPr>
       <p:sp>
         <p:nvSpPr>
           <p:cNvPr id="2" name="TextBox 1"/>
@@ -8572,7 +8186,7 @@
         </p:nvGraphicFramePr>
         <p:xfrm>
           <a:off x="640080" y="2011680"/>
-          <a:ext cx="10881360" cy="1828800"/>
+          <a:ext cx="10881360" cy="1920240"/>
         </p:xfrm>
         <a:graphic>
           <a:graphicData uri="http://schemas.openxmlformats.org/drawingml/2006/table">
@@ -8581,9 +8195,27 @@
                 <a:tableStyleId>{5C22544A-7EE6-4342-B048-85BDC9FD1C3A}</a:tableStyleId>
               </a:tblPr>
               <a:tblGrid>
-                <a:gridCol w="3627120"/>
-                <a:gridCol w="3627120"/>
-                <a:gridCol w="3627120"/>
+                <a:gridCol w="3627120">
+                  <a:extLst>
+                    <a:ext uri="{9D8B030D-6E8A-4147-A177-3AD203B41FA5}">
+                      <a16:colId xmlns:a16="http://schemas.microsoft.com/office/drawing/2014/main" val="20000"/>
+                    </a:ext>
+                  </a:extLst>
+                </a:gridCol>
+                <a:gridCol w="3627120">
+                  <a:extLst>
+                    <a:ext uri="{9D8B030D-6E8A-4147-A177-3AD203B41FA5}">
+                      <a16:colId xmlns:a16="http://schemas.microsoft.com/office/drawing/2014/main" val="20001"/>
+                    </a:ext>
+                  </a:extLst>
+                </a:gridCol>
+                <a:gridCol w="3627120">
+                  <a:extLst>
+                    <a:ext uri="{9D8B030D-6E8A-4147-A177-3AD203B41FA5}">
+                      <a16:colId xmlns:a16="http://schemas.microsoft.com/office/drawing/2014/main" val="20002"/>
+                    </a:ext>
+                  </a:extLst>
+                </a:gridCol>
               </a:tblGrid>
               <a:tr h="457200">
                 <a:tc>
@@ -8655,6 +8287,11 @@
                     </a:solidFill>
                   </a:tcPr>
                 </a:tc>
+                <a:extLst>
+                  <a:ext uri="{0D108BD9-81ED-4DB2-BD59-A6C34878D82A}">
+                    <a16:rowId xmlns:a16="http://schemas.microsoft.com/office/drawing/2014/main" val="10000"/>
+                  </a:ext>
+                </a:extLst>
               </a:tr>
               <a:tr h="457200">
                 <a:tc>
@@ -8726,6 +8363,11 @@
                     </a:solidFill>
                   </a:tcPr>
                 </a:tc>
+                <a:extLst>
+                  <a:ext uri="{0D108BD9-81ED-4DB2-BD59-A6C34878D82A}">
+                    <a16:rowId xmlns:a16="http://schemas.microsoft.com/office/drawing/2014/main" val="10001"/>
+                  </a:ext>
+                </a:extLst>
               </a:tr>
               <a:tr h="457200">
                 <a:tc>
@@ -8797,6 +8439,11 @@
                     </a:solidFill>
                   </a:tcPr>
                 </a:tc>
+                <a:extLst>
+                  <a:ext uri="{0D108BD9-81ED-4DB2-BD59-A6C34878D82A}">
+                    <a16:rowId xmlns:a16="http://schemas.microsoft.com/office/drawing/2014/main" val="10002"/>
+                  </a:ext>
+                </a:extLst>
               </a:tr>
               <a:tr h="457200">
                 <a:tc>
@@ -8868,6 +8515,11 @@
                     </a:solidFill>
                   </a:tcPr>
                 </a:tc>
+                <a:extLst>
+                  <a:ext uri="{0D108BD9-81ED-4DB2-BD59-A6C34878D82A}">
+                    <a16:rowId xmlns:a16="http://schemas.microsoft.com/office/drawing/2014/main" val="10003"/>
+                  </a:ext>
+                </a:extLst>
               </a:tr>
             </a:tbl>
           </a:graphicData>
@@ -8882,7 +8534,7 @@
 </file>
 
 <file path=ppt/slides/slide5.xml><?xml version="1.0" encoding="utf-8"?>
-<p:sld xmlns:a="http://schemas.openxmlformats.org/drawingml/2006/main" xmlns:p="http://schemas.openxmlformats.org/presentationml/2006/main" xmlns:r="http://schemas.openxmlformats.org/officeDocument/2006/relationships">
+<p:sld xmlns:a="http://schemas.openxmlformats.org/drawingml/2006/main" xmlns:r="http://schemas.openxmlformats.org/officeDocument/2006/relationships" xmlns:p="http://schemas.openxmlformats.org/presentationml/2006/main">
   <p:cSld>
     <p:bg>
       <p:bgPr>
@@ -8898,7 +8550,14 @@
         <p:cNvGrpSpPr/>
         <p:nvPr/>
       </p:nvGrpSpPr>
-      <p:grpSpPr/>
+      <p:grpSpPr>
+        <a:xfrm>
+          <a:off x="0" y="0"/>
+          <a:ext cx="0" cy="0"/>
+          <a:chOff x="0" y="0"/>
+          <a:chExt cx="0" cy="0"/>
+        </a:xfrm>
+      </p:grpSpPr>
       <p:sp>
         <p:nvSpPr>
           <p:cNvPr id="2" name="TextBox 1"/>
@@ -9031,6 +8690,7 @@
                 </a:solidFill>
               </a:defRPr>
             </a:pPr>
+            <a:endParaRPr/>
           </a:p>
           <a:p>
             <a:pPr>
@@ -9058,6 +8718,7 @@
                 </a:solidFill>
               </a:defRPr>
             </a:pPr>
+            <a:endParaRPr/>
           </a:p>
           <a:p>
             <a:pPr>
@@ -9085,6 +8746,7 @@
                 </a:solidFill>
               </a:defRPr>
             </a:pPr>
+            <a:endParaRPr/>
           </a:p>
           <a:p>
             <a:pPr>
@@ -9127,6 +8789,7 @@
                 </a:solidFill>
               </a:defRPr>
             </a:pPr>
+            <a:endParaRPr/>
           </a:p>
           <a:p>
             <a:pPr>
@@ -9154,6 +8817,7 @@
                 </a:solidFill>
               </a:defRPr>
             </a:pPr>
+            <a:endParaRPr/>
           </a:p>
           <a:p>
             <a:pPr>
@@ -9196,7 +8860,7 @@
 </file>
 
 <file path=ppt/slides/slide6.xml><?xml version="1.0" encoding="utf-8"?>
-<p:sld xmlns:a="http://schemas.openxmlformats.org/drawingml/2006/main" xmlns:p="http://schemas.openxmlformats.org/presentationml/2006/main" xmlns:r="http://schemas.openxmlformats.org/officeDocument/2006/relationships">
+<p:sld xmlns:a="http://schemas.openxmlformats.org/drawingml/2006/main" xmlns:r="http://schemas.openxmlformats.org/officeDocument/2006/relationships" xmlns:p="http://schemas.openxmlformats.org/presentationml/2006/main">
   <p:cSld>
     <p:bg>
       <p:bgPr>
@@ -9212,7 +8876,14 @@
         <p:cNvGrpSpPr/>
         <p:nvPr/>
       </p:nvGrpSpPr>
-      <p:grpSpPr/>
+      <p:grpSpPr>
+        <a:xfrm>
+          <a:off x="0" y="0"/>
+          <a:ext cx="0" cy="0"/>
+          <a:chOff x="0" y="0"/>
+          <a:chExt cx="0" cy="0"/>
+        </a:xfrm>
+      </p:grpSpPr>
       <p:sp>
         <p:nvSpPr>
           <p:cNvPr id="2" name="TextBox 1"/>
@@ -9420,7 +9091,7 @@
 </file>
 
 <file path=ppt/slides/slide7.xml><?xml version="1.0" encoding="utf-8"?>
-<p:sld xmlns:a="http://schemas.openxmlformats.org/drawingml/2006/main" xmlns:p="http://schemas.openxmlformats.org/presentationml/2006/main" xmlns:r="http://schemas.openxmlformats.org/officeDocument/2006/relationships">
+<p:sld xmlns:a="http://schemas.openxmlformats.org/drawingml/2006/main" xmlns:r="http://schemas.openxmlformats.org/officeDocument/2006/relationships" xmlns:p="http://schemas.openxmlformats.org/presentationml/2006/main">
   <p:cSld>
     <p:bg>
       <p:bgPr>
@@ -9436,7 +9107,14 @@
         <p:cNvGrpSpPr/>
         <p:nvPr/>
       </p:nvGrpSpPr>
-      <p:grpSpPr/>
+      <p:grpSpPr>
+        <a:xfrm>
+          <a:off x="0" y="0"/>
+          <a:ext cx="0" cy="0"/>
+          <a:chOff x="0" y="0"/>
+          <a:chExt cx="0" cy="0"/>
+        </a:xfrm>
+      </p:grpSpPr>
       <p:sp>
         <p:nvSpPr>
           <p:cNvPr id="2" name="TextBox 1"/>
@@ -9584,6 +9262,7 @@
                 </a:solidFill>
               </a:defRPr>
             </a:pPr>
+            <a:endParaRPr/>
           </a:p>
           <a:p>
             <a:pPr>
@@ -9626,6 +9305,7 @@
                 </a:solidFill>
               </a:defRPr>
             </a:pPr>
+            <a:endParaRPr/>
           </a:p>
           <a:p>
             <a:pPr>
@@ -9683,7 +9363,7 @@
 </file>
 
 <file path=ppt/slides/slide8.xml><?xml version="1.0" encoding="utf-8"?>
-<p:sld xmlns:a="http://schemas.openxmlformats.org/drawingml/2006/main" xmlns:p="http://schemas.openxmlformats.org/presentationml/2006/main" xmlns:r="http://schemas.openxmlformats.org/officeDocument/2006/relationships">
+<p:sld xmlns:a="http://schemas.openxmlformats.org/drawingml/2006/main" xmlns:r="http://schemas.openxmlformats.org/officeDocument/2006/relationships" xmlns:p="http://schemas.openxmlformats.org/presentationml/2006/main">
   <p:cSld>
     <p:bg>
       <p:bgPr>
@@ -9699,7 +9379,14 @@
         <p:cNvGrpSpPr/>
         <p:nvPr/>
       </p:nvGrpSpPr>
-      <p:grpSpPr/>
+      <p:grpSpPr>
+        <a:xfrm>
+          <a:off x="0" y="0"/>
+          <a:ext cx="0" cy="0"/>
+          <a:chOff x="0" y="0"/>
+          <a:chExt cx="0" cy="0"/>
+        </a:xfrm>
+      </p:grpSpPr>
       <p:sp>
         <p:nvSpPr>
           <p:cNvPr id="2" name="TextBox 1"/>
@@ -9780,7 +9467,7 @@
         </p:nvGraphicFramePr>
         <p:xfrm>
           <a:off x="640080" y="2011680"/>
-          <a:ext cx="10881360" cy="1828800"/>
+          <a:ext cx="10881360" cy="1859280"/>
         </p:xfrm>
         <a:graphic>
           <a:graphicData uri="http://schemas.openxmlformats.org/drawingml/2006/table">
@@ -9789,10 +9476,34 @@
                 <a:tableStyleId>{5C22544A-7EE6-4342-B048-85BDC9FD1C3A}</a:tableStyleId>
               </a:tblPr>
               <a:tblGrid>
-                <a:gridCol w="2720340"/>
-                <a:gridCol w="2720340"/>
-                <a:gridCol w="2720340"/>
-                <a:gridCol w="2720340"/>
+                <a:gridCol w="2720340">
+                  <a:extLst>
+                    <a:ext uri="{9D8B030D-6E8A-4147-A177-3AD203B41FA5}">
+                      <a16:colId xmlns:a16="http://schemas.microsoft.com/office/drawing/2014/main" val="20000"/>
+                    </a:ext>
+                  </a:extLst>
+                </a:gridCol>
+                <a:gridCol w="2720340">
+                  <a:extLst>
+                    <a:ext uri="{9D8B030D-6E8A-4147-A177-3AD203B41FA5}">
+                      <a16:colId xmlns:a16="http://schemas.microsoft.com/office/drawing/2014/main" val="20001"/>
+                    </a:ext>
+                  </a:extLst>
+                </a:gridCol>
+                <a:gridCol w="2720340">
+                  <a:extLst>
+                    <a:ext uri="{9D8B030D-6E8A-4147-A177-3AD203B41FA5}">
+                      <a16:colId xmlns:a16="http://schemas.microsoft.com/office/drawing/2014/main" val="20002"/>
+                    </a:ext>
+                  </a:extLst>
+                </a:gridCol>
+                <a:gridCol w="2720340">
+                  <a:extLst>
+                    <a:ext uri="{9D8B030D-6E8A-4147-A177-3AD203B41FA5}">
+                      <a16:colId xmlns:a16="http://schemas.microsoft.com/office/drawing/2014/main" val="20003"/>
+                    </a:ext>
+                  </a:extLst>
+                </a:gridCol>
               </a:tblGrid>
               <a:tr h="457200">
                 <a:tc>
@@ -9887,6 +9598,11 @@
                     </a:solidFill>
                   </a:tcPr>
                 </a:tc>
+                <a:extLst>
+                  <a:ext uri="{0D108BD9-81ED-4DB2-BD59-A6C34878D82A}">
+                    <a16:rowId xmlns:a16="http://schemas.microsoft.com/office/drawing/2014/main" val="10000"/>
+                  </a:ext>
+                </a:extLst>
               </a:tr>
               <a:tr h="457200">
                 <a:tc>
@@ -9981,6 +9697,11 @@
                     </a:solidFill>
                   </a:tcPr>
                 </a:tc>
+                <a:extLst>
+                  <a:ext uri="{0D108BD9-81ED-4DB2-BD59-A6C34878D82A}">
+                    <a16:rowId xmlns:a16="http://schemas.microsoft.com/office/drawing/2014/main" val="10001"/>
+                  </a:ext>
+                </a:extLst>
               </a:tr>
               <a:tr h="457200">
                 <a:tc>
@@ -10075,6 +9796,11 @@
                     </a:solidFill>
                   </a:tcPr>
                 </a:tc>
+                <a:extLst>
+                  <a:ext uri="{0D108BD9-81ED-4DB2-BD59-A6C34878D82A}">
+                    <a16:rowId xmlns:a16="http://schemas.microsoft.com/office/drawing/2014/main" val="10002"/>
+                  </a:ext>
+                </a:extLst>
               </a:tr>
               <a:tr h="457200">
                 <a:tc>
@@ -10169,6 +9895,11 @@
                     </a:solidFill>
                   </a:tcPr>
                 </a:tc>
+                <a:extLst>
+                  <a:ext uri="{0D108BD9-81ED-4DB2-BD59-A6C34878D82A}">
+                    <a16:rowId xmlns:a16="http://schemas.microsoft.com/office/drawing/2014/main" val="10003"/>
+                  </a:ext>
+                </a:extLst>
               </a:tr>
             </a:tbl>
           </a:graphicData>
@@ -10251,7 +9982,7 @@
 </file>
 
 <file path=ppt/slides/slide9.xml><?xml version="1.0" encoding="utf-8"?>
-<p:sld xmlns:a="http://schemas.openxmlformats.org/drawingml/2006/main" xmlns:p="http://schemas.openxmlformats.org/presentationml/2006/main" xmlns:r="http://schemas.openxmlformats.org/officeDocument/2006/relationships">
+<p:sld xmlns:a="http://schemas.openxmlformats.org/drawingml/2006/main" xmlns:r="http://schemas.openxmlformats.org/officeDocument/2006/relationships" xmlns:p="http://schemas.openxmlformats.org/presentationml/2006/main">
   <p:cSld>
     <p:bg>
       <p:bgPr>
@@ -10267,7 +9998,14 @@
         <p:cNvGrpSpPr/>
         <p:nvPr/>
       </p:nvGrpSpPr>
-      <p:grpSpPr/>
+      <p:grpSpPr>
+        <a:xfrm>
+          <a:off x="0" y="0"/>
+          <a:ext cx="0" cy="0"/>
+          <a:chOff x="0" y="0"/>
+          <a:chExt cx="0" cy="0"/>
+        </a:xfrm>
+      </p:grpSpPr>
       <p:sp>
         <p:nvSpPr>
           <p:cNvPr id="2" name="TextBox 1"/>
@@ -10322,9 +10060,27 @@
                 <a:tableStyleId>{5C22544A-7EE6-4342-B048-85BDC9FD1C3A}</a:tableStyleId>
               </a:tblPr>
               <a:tblGrid>
-                <a:gridCol w="3627120"/>
-                <a:gridCol w="3627120"/>
-                <a:gridCol w="3627120"/>
+                <a:gridCol w="3627120">
+                  <a:extLst>
+                    <a:ext uri="{9D8B030D-6E8A-4147-A177-3AD203B41FA5}">
+                      <a16:colId xmlns:a16="http://schemas.microsoft.com/office/drawing/2014/main" val="20000"/>
+                    </a:ext>
+                  </a:extLst>
+                </a:gridCol>
+                <a:gridCol w="3627120">
+                  <a:extLst>
+                    <a:ext uri="{9D8B030D-6E8A-4147-A177-3AD203B41FA5}">
+                      <a16:colId xmlns:a16="http://schemas.microsoft.com/office/drawing/2014/main" val="20001"/>
+                    </a:ext>
+                  </a:extLst>
+                </a:gridCol>
+                <a:gridCol w="3627120">
+                  <a:extLst>
+                    <a:ext uri="{9D8B030D-6E8A-4147-A177-3AD203B41FA5}">
+                      <a16:colId xmlns:a16="http://schemas.microsoft.com/office/drawing/2014/main" val="20002"/>
+                    </a:ext>
+                  </a:extLst>
+                </a:gridCol>
               </a:tblGrid>
               <a:tr h="457200">
                 <a:tc>
@@ -10396,6 +10152,11 @@
                     </a:solidFill>
                   </a:tcPr>
                 </a:tc>
+                <a:extLst>
+                  <a:ext uri="{0D108BD9-81ED-4DB2-BD59-A6C34878D82A}">
+                    <a16:rowId xmlns:a16="http://schemas.microsoft.com/office/drawing/2014/main" val="10000"/>
+                  </a:ext>
+                </a:extLst>
               </a:tr>
               <a:tr h="457200">
                 <a:tc>
@@ -10467,6 +10228,11 @@
                     </a:solidFill>
                   </a:tcPr>
                 </a:tc>
+                <a:extLst>
+                  <a:ext uri="{0D108BD9-81ED-4DB2-BD59-A6C34878D82A}">
+                    <a16:rowId xmlns:a16="http://schemas.microsoft.com/office/drawing/2014/main" val="10001"/>
+                  </a:ext>
+                </a:extLst>
               </a:tr>
               <a:tr h="457200">
                 <a:tc>
@@ -10538,6 +10304,11 @@
                     </a:solidFill>
                   </a:tcPr>
                 </a:tc>
+                <a:extLst>
+                  <a:ext uri="{0D108BD9-81ED-4DB2-BD59-A6C34878D82A}">
+                    <a16:rowId xmlns:a16="http://schemas.microsoft.com/office/drawing/2014/main" val="10002"/>
+                  </a:ext>
+                </a:extLst>
               </a:tr>
               <a:tr h="457200">
                 <a:tc>
@@ -10609,6 +10380,11 @@
                     </a:solidFill>
                   </a:tcPr>
                 </a:tc>
+                <a:extLst>
+                  <a:ext uri="{0D108BD9-81ED-4DB2-BD59-A6C34878D82A}">
+                    <a16:rowId xmlns:a16="http://schemas.microsoft.com/office/drawing/2014/main" val="10003"/>
+                  </a:ext>
+                </a:extLst>
               </a:tr>
               <a:tr h="457200">
                 <a:tc>
@@ -10680,6 +10456,11 @@
                     </a:solidFill>
                   </a:tcPr>
                 </a:tc>
+                <a:extLst>
+                  <a:ext uri="{0D108BD9-81ED-4DB2-BD59-A6C34878D82A}">
+                    <a16:rowId xmlns:a16="http://schemas.microsoft.com/office/drawing/2014/main" val="10004"/>
+                  </a:ext>
+                </a:extLst>
               </a:tr>
               <a:tr h="457200">
                 <a:tc>
@@ -10751,6 +10532,11 @@
                     </a:solidFill>
                   </a:tcPr>
                 </a:tc>
+                <a:extLst>
+                  <a:ext uri="{0D108BD9-81ED-4DB2-BD59-A6C34878D82A}">
+                    <a16:rowId xmlns:a16="http://schemas.microsoft.com/office/drawing/2014/main" val="10005"/>
+                  </a:ext>
+                </a:extLst>
               </a:tr>
             </a:tbl>
           </a:graphicData>

</xml_diff>